<commit_message>
updated week 10 notes
</commit_message>
<xml_diff>
--- a/notes/week11/BasicSorting.pptx
+++ b/notes/week11/BasicSorting.pptx
@@ -145,7 +145,7 @@
 <file path=ppt/revisionInfo.xml><?xml version="1.0" encoding="utf-8"?>
 <p1510:revInfo xmlns:a="http://schemas.openxmlformats.org/drawingml/2006/main" xmlns:r="http://schemas.openxmlformats.org/officeDocument/2006/relationships" xmlns:p1510="http://schemas.microsoft.com/office/powerpoint/2015/10/main">
   <p1510:revLst>
-    <p1510:client id="{99BD037A-9A09-894F-8D8F-3636741C8D05}" v="11" dt="2026-03-16T04:11:24.836"/>
+    <p1510:client id="{99BD037A-9A09-894F-8D8F-3636741C8D05}" v="15" dt="2026-03-19T17:22:12.972"/>
   </p1510:revLst>
 </p1510:revInfo>
 </file>
@@ -155,7 +155,7 @@
   <pc:docChgLst>
     <pc:chgData name="Toby Donaldson" userId="2e6e5431-bb17-4c41-9985-d39c50d83c73" providerId="ADAL" clId="{F31BC264-820E-54C4-A6D1-F92AF9CC222E}"/>
     <pc:docChg chg="undo custSel modSld sldOrd">
-      <pc:chgData name="Toby Donaldson" userId="2e6e5431-bb17-4c41-9985-d39c50d83c73" providerId="ADAL" clId="{F31BC264-820E-54C4-A6D1-F92AF9CC222E}" dt="2026-03-16T04:23:36.040" v="325" actId="1076"/>
+      <pc:chgData name="Toby Donaldson" userId="2e6e5431-bb17-4c41-9985-d39c50d83c73" providerId="ADAL" clId="{F31BC264-820E-54C4-A6D1-F92AF9CC222E}" dt="2026-03-19T17:22:12.968" v="436"/>
       <pc:docMkLst>
         <pc:docMk/>
       </pc:docMkLst>
@@ -234,22 +234,6 @@
           <pc:docMk/>
           <pc:sldMk cId="0" sldId="261"/>
         </pc:sldMkLst>
-        <pc:spChg chg="del mod">
-          <ac:chgData name="Toby Donaldson" userId="2e6e5431-bb17-4c41-9985-d39c50d83c73" providerId="ADAL" clId="{F31BC264-820E-54C4-A6D1-F92AF9CC222E}" dt="2026-03-16T03:53:49.195" v="41" actId="21"/>
-          <ac:spMkLst>
-            <pc:docMk/>
-            <pc:sldMk cId="0" sldId="261"/>
-            <ac:spMk id="10" creationId="{00000000-0000-0000-0000-000000000000}"/>
-          </ac:spMkLst>
-        </pc:spChg>
-        <pc:spChg chg="del mod">
-          <ac:chgData name="Toby Donaldson" userId="2e6e5431-bb17-4c41-9985-d39c50d83c73" providerId="ADAL" clId="{F31BC264-820E-54C4-A6D1-F92AF9CC222E}" dt="2026-03-16T03:53:53.860" v="42" actId="21"/>
-          <ac:spMkLst>
-            <pc:docMk/>
-            <pc:sldMk cId="0" sldId="261"/>
-            <ac:spMk id="11" creationId="{00000000-0000-0000-0000-000000000000}"/>
-          </ac:spMkLst>
-        </pc:spChg>
         <pc:spChg chg="mod">
           <ac:chgData name="Toby Donaldson" userId="2e6e5431-bb17-4c41-9985-d39c50d83c73" providerId="ADAL" clId="{F31BC264-820E-54C4-A6D1-F92AF9CC222E}" dt="2026-03-16T03:53:59.002" v="43" actId="14100"/>
           <ac:spMkLst>
@@ -305,14 +289,6 @@
             <ac:spMk id="5" creationId="{00000000-0000-0000-0000-000000000000}"/>
           </ac:spMkLst>
         </pc:spChg>
-        <pc:spChg chg="del">
-          <ac:chgData name="Toby Donaldson" userId="2e6e5431-bb17-4c41-9985-d39c50d83c73" providerId="ADAL" clId="{F31BC264-820E-54C4-A6D1-F92AF9CC222E}" dt="2026-03-16T03:56:08.133" v="52" actId="21"/>
-          <ac:spMkLst>
-            <pc:docMk/>
-            <pc:sldMk cId="0" sldId="262"/>
-            <ac:spMk id="6" creationId="{00000000-0000-0000-0000-000000000000}"/>
-          </ac:spMkLst>
-        </pc:spChg>
         <pc:spChg chg="mod">
           <ac:chgData name="Toby Donaldson" userId="2e6e5431-bb17-4c41-9985-d39c50d83c73" providerId="ADAL" clId="{F31BC264-820E-54C4-A6D1-F92AF9CC222E}" dt="2026-03-16T03:57:45.468" v="66" actId="1076"/>
           <ac:spMkLst>
@@ -327,14 +303,6 @@
             <pc:docMk/>
             <pc:sldMk cId="0" sldId="262"/>
             <ac:spMk id="8" creationId="{00000000-0000-0000-0000-000000000000}"/>
-          </ac:spMkLst>
-        </pc:spChg>
-        <pc:spChg chg="del">
-          <ac:chgData name="Toby Donaldson" userId="2e6e5431-bb17-4c41-9985-d39c50d83c73" providerId="ADAL" clId="{F31BC264-820E-54C4-A6D1-F92AF9CC222E}" dt="2026-03-16T03:56:08.133" v="52" actId="21"/>
-          <ac:spMkLst>
-            <pc:docMk/>
-            <pc:sldMk cId="0" sldId="262"/>
-            <ac:spMk id="9" creationId="{00000000-0000-0000-0000-000000000000}"/>
           </ac:spMkLst>
         </pc:spChg>
         <pc:spChg chg="mod">
@@ -353,14 +321,6 @@
             <ac:spMk id="11" creationId="{00000000-0000-0000-0000-000000000000}"/>
           </ac:spMkLst>
         </pc:spChg>
-        <pc:spChg chg="del">
-          <ac:chgData name="Toby Donaldson" userId="2e6e5431-bb17-4c41-9985-d39c50d83c73" providerId="ADAL" clId="{F31BC264-820E-54C4-A6D1-F92AF9CC222E}" dt="2026-03-16T03:56:08.133" v="52" actId="21"/>
-          <ac:spMkLst>
-            <pc:docMk/>
-            <pc:sldMk cId="0" sldId="262"/>
-            <ac:spMk id="12" creationId="{00000000-0000-0000-0000-000000000000}"/>
-          </ac:spMkLst>
-        </pc:spChg>
         <pc:spChg chg="mod">
           <ac:chgData name="Toby Donaldson" userId="2e6e5431-bb17-4c41-9985-d39c50d83c73" providerId="ADAL" clId="{F31BC264-820E-54C4-A6D1-F92AF9CC222E}" dt="2026-03-16T03:57:45.468" v="66" actId="1076"/>
           <ac:spMkLst>
@@ -377,14 +337,6 @@
             <ac:spMk id="14" creationId="{00000000-0000-0000-0000-000000000000}"/>
           </ac:spMkLst>
         </pc:spChg>
-        <pc:spChg chg="del">
-          <ac:chgData name="Toby Donaldson" userId="2e6e5431-bb17-4c41-9985-d39c50d83c73" providerId="ADAL" clId="{F31BC264-820E-54C4-A6D1-F92AF9CC222E}" dt="2026-03-16T03:56:08.133" v="52" actId="21"/>
-          <ac:spMkLst>
-            <pc:docMk/>
-            <pc:sldMk cId="0" sldId="262"/>
-            <ac:spMk id="15" creationId="{00000000-0000-0000-0000-000000000000}"/>
-          </ac:spMkLst>
-        </pc:spChg>
         <pc:spChg chg="mod">
           <ac:chgData name="Toby Donaldson" userId="2e6e5431-bb17-4c41-9985-d39c50d83c73" providerId="ADAL" clId="{F31BC264-820E-54C4-A6D1-F92AF9CC222E}" dt="2026-03-16T03:57:45.468" v="66" actId="1076"/>
           <ac:spMkLst>
@@ -399,14 +351,6 @@
             <pc:docMk/>
             <pc:sldMk cId="0" sldId="262"/>
             <ac:spMk id="17" creationId="{00000000-0000-0000-0000-000000000000}"/>
-          </ac:spMkLst>
-        </pc:spChg>
-        <pc:spChg chg="del">
-          <ac:chgData name="Toby Donaldson" userId="2e6e5431-bb17-4c41-9985-d39c50d83c73" providerId="ADAL" clId="{F31BC264-820E-54C4-A6D1-F92AF9CC222E}" dt="2026-03-16T03:56:08.133" v="52" actId="21"/>
-          <ac:spMkLst>
-            <pc:docMk/>
-            <pc:sldMk cId="0" sldId="262"/>
-            <ac:spMk id="18" creationId="{00000000-0000-0000-0000-000000000000}"/>
           </ac:spMkLst>
         </pc:spChg>
         <pc:spChg chg="mod">
@@ -448,17 +392,9 @@
             <ac:spMk id="17" creationId="{00000000-0000-0000-0000-000000000000}"/>
           </ac:spMkLst>
         </pc:spChg>
-        <pc:spChg chg="del">
-          <ac:chgData name="Toby Donaldson" userId="2e6e5431-bb17-4c41-9985-d39c50d83c73" providerId="ADAL" clId="{F31BC264-820E-54C4-A6D1-F92AF9CC222E}" dt="2026-03-16T04:01:55.612" v="95" actId="21"/>
-          <ac:spMkLst>
-            <pc:docMk/>
-            <pc:sldMk cId="0" sldId="263"/>
-            <ac:spMk id="19" creationId="{00000000-0000-0000-0000-000000000000}"/>
-          </ac:spMkLst>
-        </pc:spChg>
       </pc:sldChg>
-      <pc:sldChg chg="modSp mod ord">
-        <pc:chgData name="Toby Donaldson" userId="2e6e5431-bb17-4c41-9985-d39c50d83c73" providerId="ADAL" clId="{F31BC264-820E-54C4-A6D1-F92AF9CC222E}" dt="2026-03-16T04:01:42.056" v="94" actId="20578"/>
+      <pc:sldChg chg="addSp modSp mod ord">
+        <pc:chgData name="Toby Donaldson" userId="2e6e5431-bb17-4c41-9985-d39c50d83c73" providerId="ADAL" clId="{F31BC264-820E-54C4-A6D1-F92AF9CC222E}" dt="2026-03-18T18:16:12.490" v="423" actId="1076"/>
         <pc:sldMkLst>
           <pc:docMk/>
           <pc:sldMk cId="0" sldId="264"/>
@@ -479,9 +415,25 @@
             <ac:spMk id="5" creationId="{00000000-0000-0000-0000-000000000000}"/>
           </ac:spMkLst>
         </pc:spChg>
+        <pc:spChg chg="mod">
+          <ac:chgData name="Toby Donaldson" userId="2e6e5431-bb17-4c41-9985-d39c50d83c73" providerId="ADAL" clId="{F31BC264-820E-54C4-A6D1-F92AF9CC222E}" dt="2026-03-18T18:14:14.328" v="343" actId="20577"/>
+          <ac:spMkLst>
+            <pc:docMk/>
+            <pc:sldMk cId="0" sldId="264"/>
+            <ac:spMk id="6" creationId="{00000000-0000-0000-0000-000000000000}"/>
+          </ac:spMkLst>
+        </pc:spChg>
+        <pc:spChg chg="add mod">
+          <ac:chgData name="Toby Donaldson" userId="2e6e5431-bb17-4c41-9985-d39c50d83c73" providerId="ADAL" clId="{F31BC264-820E-54C4-A6D1-F92AF9CC222E}" dt="2026-03-18T18:16:12.490" v="423" actId="1076"/>
+          <ac:spMkLst>
+            <pc:docMk/>
+            <pc:sldMk cId="0" sldId="264"/>
+            <ac:spMk id="7" creationId="{E85ADFE7-71F3-7486-4513-62200AEEEDAD}"/>
+          </ac:spMkLst>
+        </pc:spChg>
       </pc:sldChg>
-      <pc:sldChg chg="modSp mod">
-        <pc:chgData name="Toby Donaldson" userId="2e6e5431-bb17-4c41-9985-d39c50d83c73" providerId="ADAL" clId="{F31BC264-820E-54C4-A6D1-F92AF9CC222E}" dt="2026-03-16T04:09:46.828" v="201"/>
+      <pc:sldChg chg="addSp modSp mod">
+        <pc:chgData name="Toby Donaldson" userId="2e6e5431-bb17-4c41-9985-d39c50d83c73" providerId="ADAL" clId="{F31BC264-820E-54C4-A6D1-F92AF9CC222E}" dt="2026-03-18T20:01:18.164" v="434"/>
         <pc:sldMkLst>
           <pc:docMk/>
           <pc:sldMk cId="0" sldId="266"/>
@@ -510,9 +462,17 @@
             <ac:graphicFrameMk id="12" creationId="{00000000-0000-0000-0000-000000000000}"/>
           </ac:graphicFrameMkLst>
         </pc:graphicFrameChg>
+        <pc:inkChg chg="add">
+          <ac:chgData name="Toby Donaldson" userId="2e6e5431-bb17-4c41-9985-d39c50d83c73" providerId="ADAL" clId="{F31BC264-820E-54C4-A6D1-F92AF9CC222E}" dt="2026-03-18T20:01:18.164" v="434"/>
+          <ac:inkMkLst>
+            <pc:docMk/>
+            <pc:sldMk cId="0" sldId="266"/>
+            <ac:inkMk id="5" creationId="{245D4A59-B75D-CDE3-C4E6-F40CF6C97054}"/>
+          </ac:inkMkLst>
+        </pc:inkChg>
       </pc:sldChg>
-      <pc:sldChg chg="modSp mod">
-        <pc:chgData name="Toby Donaldson" userId="2e6e5431-bb17-4c41-9985-d39c50d83c73" providerId="ADAL" clId="{F31BC264-820E-54C4-A6D1-F92AF9CC222E}" dt="2026-03-16T04:12:02.068" v="296" actId="20577"/>
+      <pc:sldChg chg="addSp modSp mod">
+        <pc:chgData name="Toby Donaldson" userId="2e6e5431-bb17-4c41-9985-d39c50d83c73" providerId="ADAL" clId="{F31BC264-820E-54C4-A6D1-F92AF9CC222E}" dt="2026-03-18T20:01:18.164" v="434"/>
         <pc:sldMkLst>
           <pc:docMk/>
           <pc:sldMk cId="0" sldId="267"/>
@@ -541,6 +501,29 @@
             <ac:spMk id="9" creationId="{00000000-0000-0000-0000-000000000000}"/>
           </ac:spMkLst>
         </pc:spChg>
+        <pc:inkChg chg="add">
+          <ac:chgData name="Toby Donaldson" userId="2e6e5431-bb17-4c41-9985-d39c50d83c73" providerId="ADAL" clId="{F31BC264-820E-54C4-A6D1-F92AF9CC222E}" dt="2026-03-18T20:01:18.164" v="434"/>
+          <ac:inkMkLst>
+            <pc:docMk/>
+            <pc:sldMk cId="0" sldId="267"/>
+            <ac:inkMk id="8" creationId="{2F7FAA2A-3FF9-F1E8-4D9C-6475248091C4}"/>
+          </ac:inkMkLst>
+        </pc:inkChg>
+      </pc:sldChg>
+      <pc:sldChg chg="addSp">
+        <pc:chgData name="Toby Donaldson" userId="2e6e5431-bb17-4c41-9985-d39c50d83c73" providerId="ADAL" clId="{F31BC264-820E-54C4-A6D1-F92AF9CC222E}" dt="2026-03-18T20:10:36.953" v="435"/>
+        <pc:sldMkLst>
+          <pc:docMk/>
+          <pc:sldMk cId="0" sldId="269"/>
+        </pc:sldMkLst>
+        <pc:inkChg chg="add">
+          <ac:chgData name="Toby Donaldson" userId="2e6e5431-bb17-4c41-9985-d39c50d83c73" providerId="ADAL" clId="{F31BC264-820E-54C4-A6D1-F92AF9CC222E}" dt="2026-03-18T20:10:36.953" v="435"/>
+          <ac:inkMkLst>
+            <pc:docMk/>
+            <pc:sldMk cId="0" sldId="269"/>
+            <ac:inkMk id="22" creationId="{3E8A1C78-3F6C-D43E-C215-349264907BF0}"/>
+          </ac:inkMkLst>
+        </pc:inkChg>
       </pc:sldChg>
       <pc:sldChg chg="modSp mod">
         <pc:chgData name="Toby Donaldson" userId="2e6e5431-bb17-4c41-9985-d39c50d83c73" providerId="ADAL" clId="{F31BC264-820E-54C4-A6D1-F92AF9CC222E}" dt="2026-03-16T04:13:27.699" v="307" actId="207"/>
@@ -565,8 +548,8 @@
           </ac:graphicFrameMkLst>
         </pc:graphicFrameChg>
       </pc:sldChg>
-      <pc:sldChg chg="modSp mod">
-        <pc:chgData name="Toby Donaldson" userId="2e6e5431-bb17-4c41-9985-d39c50d83c73" providerId="ADAL" clId="{F31BC264-820E-54C4-A6D1-F92AF9CC222E}" dt="2026-03-16T04:15:32.621" v="309" actId="20577"/>
+      <pc:sldChg chg="addSp modSp mod">
+        <pc:chgData name="Toby Donaldson" userId="2e6e5431-bb17-4c41-9985-d39c50d83c73" providerId="ADAL" clId="{F31BC264-820E-54C4-A6D1-F92AF9CC222E}" dt="2026-03-18T20:10:36.953" v="435"/>
         <pc:sldMkLst>
           <pc:docMk/>
           <pc:sldMk cId="0" sldId="271"/>
@@ -579,9 +562,17 @@
             <ac:spMk id="5" creationId="{00000000-0000-0000-0000-000000000000}"/>
           </ac:spMkLst>
         </pc:spChg>
+        <pc:inkChg chg="add">
+          <ac:chgData name="Toby Donaldson" userId="2e6e5431-bb17-4c41-9985-d39c50d83c73" providerId="ADAL" clId="{F31BC264-820E-54C4-A6D1-F92AF9CC222E}" dt="2026-03-18T20:10:36.953" v="435"/>
+          <ac:inkMkLst>
+            <pc:docMk/>
+            <pc:sldMk cId="0" sldId="271"/>
+            <ac:inkMk id="10" creationId="{104F93F5-5D3A-9CE9-A1F8-022A9BD05F83}"/>
+          </ac:inkMkLst>
+        </pc:inkChg>
       </pc:sldChg>
-      <pc:sldChg chg="modSp mod">
-        <pc:chgData name="Toby Donaldson" userId="2e6e5431-bb17-4c41-9985-d39c50d83c73" providerId="ADAL" clId="{F31BC264-820E-54C4-A6D1-F92AF9CC222E}" dt="2026-03-16T04:16:17.965" v="315" actId="20577"/>
+      <pc:sldChg chg="addSp modSp mod">
+        <pc:chgData name="Toby Donaldson" userId="2e6e5431-bb17-4c41-9985-d39c50d83c73" providerId="ADAL" clId="{F31BC264-820E-54C4-A6D1-F92AF9CC222E}" dt="2026-03-19T17:22:12.968" v="436"/>
         <pc:sldMkLst>
           <pc:docMk/>
           <pc:sldMk cId="0" sldId="272"/>
@@ -594,9 +585,32 @@
             <ac:spMk id="5" creationId="{00000000-0000-0000-0000-000000000000}"/>
           </ac:spMkLst>
         </pc:spChg>
+        <pc:inkChg chg="add">
+          <ac:chgData name="Toby Donaldson" userId="2e6e5431-bb17-4c41-9985-d39c50d83c73" providerId="ADAL" clId="{F31BC264-820E-54C4-A6D1-F92AF9CC222E}" dt="2026-03-19T17:22:12.968" v="436"/>
+          <ac:inkMkLst>
+            <pc:docMk/>
+            <pc:sldMk cId="0" sldId="272"/>
+            <ac:inkMk id="22" creationId="{4609A55C-A692-B156-6516-C2AAE396F40A}"/>
+          </ac:inkMkLst>
+        </pc:inkChg>
       </pc:sldChg>
-      <pc:sldChg chg="modSp mod">
-        <pc:chgData name="Toby Donaldson" userId="2e6e5431-bb17-4c41-9985-d39c50d83c73" providerId="ADAL" clId="{F31BC264-820E-54C4-A6D1-F92AF9CC222E}" dt="2026-03-16T04:18:28.277" v="316" actId="113"/>
+      <pc:sldChg chg="addSp">
+        <pc:chgData name="Toby Donaldson" userId="2e6e5431-bb17-4c41-9985-d39c50d83c73" providerId="ADAL" clId="{F31BC264-820E-54C4-A6D1-F92AF9CC222E}" dt="2026-03-19T17:22:12.968" v="436"/>
+        <pc:sldMkLst>
+          <pc:docMk/>
+          <pc:sldMk cId="0" sldId="273"/>
+        </pc:sldMkLst>
+        <pc:inkChg chg="add">
+          <ac:chgData name="Toby Donaldson" userId="2e6e5431-bb17-4c41-9985-d39c50d83c73" providerId="ADAL" clId="{F31BC264-820E-54C4-A6D1-F92AF9CC222E}" dt="2026-03-19T17:22:12.968" v="436"/>
+          <ac:inkMkLst>
+            <pc:docMk/>
+            <pc:sldMk cId="0" sldId="273"/>
+            <ac:inkMk id="13" creationId="{12C507E8-7E33-CAD6-21D9-FB5C2F41A7FB}"/>
+          </ac:inkMkLst>
+        </pc:inkChg>
+      </pc:sldChg>
+      <pc:sldChg chg="addSp modSp mod">
+        <pc:chgData name="Toby Donaldson" userId="2e6e5431-bb17-4c41-9985-d39c50d83c73" providerId="ADAL" clId="{F31BC264-820E-54C4-A6D1-F92AF9CC222E}" dt="2026-03-19T17:22:12.968" v="436"/>
         <pc:sldMkLst>
           <pc:docMk/>
           <pc:sldMk cId="0" sldId="274"/>
@@ -609,6 +623,14 @@
             <ac:spMk id="10" creationId="{00000000-0000-0000-0000-000000000000}"/>
           </ac:spMkLst>
         </pc:spChg>
+        <pc:inkChg chg="add">
+          <ac:chgData name="Toby Donaldson" userId="2e6e5431-bb17-4c41-9985-d39c50d83c73" providerId="ADAL" clId="{F31BC264-820E-54C4-A6D1-F92AF9CC222E}" dt="2026-03-19T17:22:12.968" v="436"/>
+          <ac:inkMkLst>
+            <pc:docMk/>
+            <pc:sldMk cId="0" sldId="274"/>
+            <ac:inkMk id="7" creationId="{7346757B-0728-00F8-AD13-1EC6452B9915}"/>
+          </ac:inkMkLst>
+        </pc:inkChg>
       </pc:sldChg>
       <pc:sldChg chg="modSp mod">
         <pc:chgData name="Toby Donaldson" userId="2e6e5431-bb17-4c41-9985-d39c50d83c73" providerId="ADAL" clId="{F31BC264-820E-54C4-A6D1-F92AF9CC222E}" dt="2026-03-16T04:21:13.379" v="319" actId="20577"/>
@@ -655,9 +677,257 @@
           </ac:spMkLst>
         </pc:spChg>
       </pc:sldChg>
+      <pc:sldChg chg="modSp mod">
+        <pc:chgData name="Toby Donaldson" userId="2e6e5431-bb17-4c41-9985-d39c50d83c73" providerId="ADAL" clId="{F31BC264-820E-54C4-A6D1-F92AF9CC222E}" dt="2026-03-18T18:21:33.307" v="433" actId="20577"/>
+        <pc:sldMkLst>
+          <pc:docMk/>
+          <pc:sldMk cId="0" sldId="284"/>
+        </pc:sldMkLst>
+        <pc:graphicFrameChg chg="modGraphic">
+          <ac:chgData name="Toby Donaldson" userId="2e6e5431-bb17-4c41-9985-d39c50d83c73" providerId="ADAL" clId="{F31BC264-820E-54C4-A6D1-F92AF9CC222E}" dt="2026-03-18T18:21:33.307" v="433" actId="20577"/>
+          <ac:graphicFrameMkLst>
+            <pc:docMk/>
+            <pc:sldMk cId="0" sldId="284"/>
+            <ac:graphicFrameMk id="30" creationId="{00000000-0000-0000-0000-000000000000}"/>
+          </ac:graphicFrameMkLst>
+        </pc:graphicFrameChg>
+      </pc:sldChg>
     </pc:docChg>
   </pc:docChgLst>
 </pc:chgInfo>
+</file>
+
+<file path=ppt/ink/ink1.xml><?xml version="1.0" encoding="utf-8"?>
+<inkml:ink xmlns:inkml="http://www.w3.org/2003/InkML">
+  <inkml:definitions>
+    <inkml:context xml:id="ctx0">
+      <inkml:inkSource xml:id="inkSrc0">
+        <inkml:traceFormat>
+          <inkml:channel name="X" type="integer" min="-2.14748E9" max="2.14748E9" units="cm"/>
+          <inkml:channel name="Y" type="integer" min="-2.14748E9" max="2.14748E9" units="cm"/>
+          <inkml:channel name="F" type="integer" max="32767" units="dev"/>
+        </inkml:traceFormat>
+        <inkml:channelProperties>
+          <inkml:channelProperty channel="X" name="resolution" value="1000" units="1/cm"/>
+          <inkml:channelProperty channel="Y" name="resolution" value="1000" units="1/cm"/>
+          <inkml:channelProperty channel="F" name="resolution" value="0" units="1/dev"/>
+        </inkml:channelProperties>
+      </inkml:inkSource>
+      <inkml:timestamp xml:id="ts0" timeString="2026-03-18T19:56:19.321"/>
+    </inkml:context>
+    <inkml:brush xml:id="br0">
+      <inkml:brushProperty name="width" value="0.05292" units="cm"/>
+      <inkml:brushProperty name="height" value="0.05292" units="cm"/>
+      <inkml:brushProperty name="color" value="#FF0000"/>
+    </inkml:brush>
+  </inkml:definitions>
+  <inkml:trace contextRef="#ctx0" brushRef="#br0">1138 5040 24575,'26'0'0,"7"0"0,-6 0 0,-8 1 0,1-2 0,-1-7 0,1-1 0,1 6 0,-1 1 0,0-7 0,0 1 0,5 6 0,0 4 0,6-2 0,-6 0 0,0 0 0,3 0 0,4 0 0,1 0 0,-5 0 0,4 0 0,0 0 0,-4 0 0,-7 0 0,-1 0 0,1 0 0,-2 0 0,10 0 0,4 0 0,-9 0 0,0 0 0,0 0 0,1 0 0,6 0 0,-1 0 0,-5 0 0,-1 0 0,9 0 0,0 0 0,-3 0 0,0 0 0,3 0 0,-1 0 0,-2 0 0,0 0 0,3 0 0,0 0 0,-2 0 0,-1 0 0,-4 0 0,1 0 0,-1 0 0,-1 0 0,-4 0 0,-1 0 0,0 0 0,0 0 0,-1 0 0,0 0 0,9 0 0,4 0 0,1 0 0,-5 0 0,-9 0 0,0 0 0,9 0 0,4 0 0,-10 0 0,0 0 0,9 0 0,-1 0 0,2 0 0,-8 0 0,0 0 0,9 0 0,1 0 0,-4 0 0,0 0 0,-3 0 0,-1 0 0,-6 0 0,-1 0 0,1-2 0,-1 4 0,9 15 0,4-12 0,0 12 0,-4-17 0,-4 0 0,2 0 0,-2 0 0,1 0 0,3 0 0,3 0 0,-1 0-194,-2 0 0,0 0 1,0 0 193,3 0 0,1 0 0,-2 0 0,1 0 0,-2 0 0,-3 0 0,-2 0 0,4 0 0,-8 0 0,-8 0 0</inkml:trace>
+  <inkml:trace contextRef="#ctx0" brushRef="#br0" timeOffset="3966">2262 4815 24575,'34'0'0,"-2"0"0,1 0 0,-5 0 0,-8 0 0,-8 12 0,-12-9 0,0 9 0,-12-12 0,9 0 0,-26 0 0,24 18 0,-24-14 0,26 14 0,-20-18 0,20 0 0,-27 0 0,26 0 0,-14 0 0,6 0 0,9 0 0,-8 0 0,-1 0 0,-9 0 0,5 0 0,-1 0 0,5-18 0,9 14 0,3-14 0,3 18 0,9 0 0,5 0 0,-12 0 0,24 0 0,-26 0 0,20 0 0,-20 18 0,27-14 0,-26 14 0,14-18 0,-18 0 0,12 0 0,-9 0 0,8 11 0,-11-8 0,0 9 0,0-12 0,0 0 0,0 0 0</inkml:trace>
+  <inkml:trace contextRef="#ctx0" brushRef="#br0" timeOffset="13249">11642 5887 24575,'31'0'0,"1"0"0,-6 0 0,1 0 0,1 0 0,3 0 0,1 0 0,0 0 0,0 0 0,-1 0 0,-1 0 0,4 0 0,-2 0 0,-8 0 0,-2 0 0,-2 0 0,-8 0 0,-12 0 0,0 0 0</inkml:trace>
+  <inkml:trace contextRef="#ctx0" brushRef="#br0" timeOffset="20132">2738 5953 24575,'15'0'0,"-3"0"0,6 0 0,-14 0 0,14 12 0,-18-9 0,0 9 0,11-12 0,-8 0 0,9 0 0,-12 0 0,18 0 0,-2 0 0,4 0 0,-8 0 0,-12 11 0,0-8 0,0 9 0,12-12 0,-9 18 0,9-14 0,-12 14 0,0-7 0,0-8 0,0 9 0,0-12 0,0 0 0</inkml:trace>
+  <inkml:trace contextRef="#ctx0" brushRef="#br0" timeOffset="26550">1693 5847 24575,'-14'0'0,"-10"0"0,4 0 0,-8 0 0,-5 0 0,19 0 0,-16 0 0,26 0 0,-14 0 0,18 0 0,0 0 0,-12 0 0,9 0 0,-26 0 0,13 0 0,-16-11 0,17 8 0,-15-9 0,26 12 0,-14 0 0,7 0 0,8 0 0,-9 0 0,0 0 0,9 0 0,-26-12 0,24 9 0,-24-9 0,8 12 0,5 0 0,-13 0 0,26 0 0,-9 0 0,12 0 0,0 0 0,-12 0 0,9 0 0,-8 0 0</inkml:trace>
+  <inkml:trace contextRef="#ctx0" brushRef="#br0" timeOffset="31449">3175 6826 24575,'22'18'0,"7"-14"0,-26 14 0,9-18 0,0 0 0,-9 0 0,9 0 0,5 0 0,-12 0 0,24 0 0,-26 0 0,9 0 0,5 0 0,-12 0 0,12 0 0,-17 0 0,0 0 0</inkml:trace>
+  <inkml:trace contextRef="#ctx0" brushRef="#br0" timeOffset="41748">3559 7832 24575,'22'0'0,"0"0"0,9 0 0,-1 0 0,1 0 0,6 0 0,-14 1 0,0-2 0,9-11 0,0 9 0,-15-9 0,0 12 0,-5 0 0,-9 0 0,20 0 0,-2 0 0,7 0 0,-8 0 0,-8 0 0,-12 0 0</inkml:trace>
+  <inkml:trace contextRef="#ctx0" brushRef="#br0" timeOffset="56500">11615 4815 24575,'0'15'0,"0"15"0,0-14 0,0 7 0,0 4 0,0-3 0,0 0 0,0 6 0,0 0 0,0 2 0,0 1 0,0 3 0,0 0 0,0-2 0,0 1-158,0-5 0,0 0 0,0 0 158,0 5 0,0-1 0,0-8 0,0 1 0,0-2 0,0 0 0,0-2 0,6 8 0,0 0 0,-5-1 0,1 0 0,7-7 0,2-1 0,-2 2-217,-6 6 0,-4 0 0,4 0 217,6-3 0,2 0 0,-2 0 0,-6 0 0,-4 0 0,2 0 0,3 3 0,0 0 0,0-1 0,-4 6 0,0 0 0,-1-6 0,1 1 0,1 0 0,2-2 0,2-2 0,-1 1 0,-3 0 0,-1 0 0,2 0 0,1 3 0,2 0 0,-2 0 0,-2 5 0,-2-1 0,1-3 0,0-2 0,0-7 0,0 0 229,0 1 1,0-2-230,0 10 0,0-6 0,0 0 0,0 3 333,0-9 0,0 0-333,0 1 0,0 0 0,0 0 0,0 1 0,0 5 0,0-1 0,0-4 0,0 0 0,0-1 0,0-1 0,0 0 0,0 0 0,0 1 0,0 0 0,0 0 0,0 1 0,0 8 0,0 0 0,0-5 0,0 0 0,0 3 0,0-1 0,0 0 0,0 0 0,0 0 0,0 0 0,0-1 0,0-1 0,0-1 0,0 0 0,0 2 0,0-1 0,0 7 0,0-9 0,0 0 0,0 11 0,0-5 0,0-3 0,0 0 0,0 6 0,0-1 0,0 1 0,0-7 0,0 1 0,0 7 0,0 2 0,0-8 0,0 0 0,0 0 0,0 9 0,0-1 0,0 3 0,0-2 0,0-8 0,0-1 0,0 0 0,0-1 0,0-4 0,0-1 0,0 0 0,0 0 0,0 0 0,0-2 0,0 10 0,0 5 0,0-1 0,0-4 0,0-7 0,0 2 0,0-20 0,0 9 0,0-12 0</inkml:trace>
+  <inkml:trace contextRef="#ctx0" brushRef="#br0" timeOffset="79532">7117 10478 24575,'30'0'0,"-1"0"0,6 0 0,2 0 0,-5-1 0,1 1 0,1 1-1043,1-1 0,1 0 1,1 0 1042,-5 0 0,1 0 0,1 0 0,-2 0 0,-1-1 0,-1 2 0,0-2 0,0 2 0,0-1 0,0 0 0,0-1 0,-1 2 102,1-1 0,-1 0 0,0 0-102,2 0 0,1 0 0,-1 0 0,-4-1 0,0 2 0,0-1 0,3 0 0,2 0 0,0 0-213,4-4 0,1-1 1,0 2 212,-9 2 0,1 0 0,-1 1 0,0-1 0,9-3 0,-1-1 0,0 2-105,-2 2 0,-1 2 1,-1-1 104,5 1 0,-2-2 0,-2-8 0,-2 0 721,-6 7 1,-1 0-722,5-7 0,-1 0 260,-7 9 1,-1 0-261,1 0 0,-2 0 1432,2 0-1432,2 0 378,-20 0-378,9 0 0,5 0 0,17 0 0,-10-5 0,1-1 0,7 4 0,0 1 0,-2-5 0,1 0 0,-5 2 0,0-1 0,0 2 0,0 2 0,-1-1 0,7-4 0,-2 0 0,-2 6 0,-9 0 0,0 0 0,9 0 0,4 0 0,-10 0 0,0 0 0,2 1 0,1-2 0,7-7 0,2-1 0,-4 7 0,0-1 0,3-6 0,-1 1 0,-2 7 0,0 2 0,4-7 0,-2 0 0,-7 5 0,-1-1 0,0-4 0,-4 0 0,-5 6 0,14 0 0,-25 0 0,26 0 0,-27 0 0,15 0 0,5 0 0,14 0 0,-8 0 0,2 0 0,2 0 0,-1 0 0,-8 0 0,0 0 0,-1 0 0,0 0 0,9 0 0,0 0 0,-4 0 0,5 0 0,-1 0 0,-9 0 0,0 0 0,13 0 0,-13 0 0,-2 0 0,12 0 0,-14 1 0,1-2 0,1-4 0,0-1 0,-2 4 0,1 1 0,6-6 0,-2 2 0,7 5 0,0 0 0,0 0 0,0 0 0,-1 0 0,1 0 0,-6 0 0,-1 0 0,8 0 0,2 0 0,-1 0 0,0 0 0,-3 0 0,1 0 0,-6 0 0,1 0 0,-1 0 0,7 0 0,-1 0 0,-5 0 0,0 0 0,0 0 0,8 0 0,-2 0 0,-2 0 0,0 0 0,2 0 0,1 0 0,3 0 0,0 0 0,-7 0 0,0 0 0,-1 0 0,1 0 0,-3-1 0,-2 2 0,7 11 0,-6-11 0,0 1 0,3 9 0,-8-11 0,-8 0 0,0 0 0,-9 0 0,8 0 0,7 12 0,-2-9 0,8 3 0,2 0 0,5-6 0,-5 8 0,-2 1 0,-8-4 0,14 12 0,-27-17 0,8 0 0</inkml:trace>
+  <inkml:trace contextRef="#ctx0" brushRef="#br0" timeOffset="117799">4657 12184 24575,'14'0'0,"16"0"0,-14 0 0,2 0 0,2 0 0,0 0 0,0 0 0,0 0 0,1 0 0,7 1 0,1-2 0,-5-7 0,1-2 0,7 8 0,1 0 0,-3-6 0,0-2 0,3 4 0,0 1 0,-3 3 0,0 1 0,-4-2 0,0-1 0,-1-1 0,0-4 0,1 0 0,-1 7 0,1 2 0,-2-2 0,1-7 0,-1 0 0,2 8 0,0 2 0,-5-1 0,-2 0 0,13 0 0,1 0 0,-17 0 0,13 0 0,-26 0 0,27 0 0,-14 0 0,4 0 0,4 0 0,-3 0 0,6 0 0,-7 0 0,-1 0 0,9 0 0,4 0 0,-10 0 0,0 0 0,9 0 0,-1 0 0,2 0 0,4 0 0,-7 0 0,0 0 0,-8 0 0,-1 0 0,0 0 0,0 0 0,5 0 0,0 0 0,5 0 0,-4 0 0,-2 0 0,4 0 0,-4-1 0,2 2 0,4 8 0,1 0 0,2-7 0,3 0-339,-4 4 0,3 1 0,-1-2 339,-6-4 0,0-2 0,0 1 0,6 3 0,2 2 0,-2-1 0,-6-4 0,-1 0 0,-1 3-63,1 5 1,-2 4-1,1-3 63,8-7 0,-2 0 0,-7 13 0,-1 0 0,7-13 0,-1-1 0,1 11 0,-6-11 0,0-2 1007,3 1-1007,5 0 99,-12 5 0,2 1-99,0-4 0,2-1 0,0 3 0,1 1 0,1-2 0,0-2 0,-1-2 0,2 1-200,2 0 0,1 0 0,0 0 200,0 0 0,0 0 0,0 0 0,2 0 0,0 0 0,0 0 0,-2 0 0,1 0 0,-1 0 0,-4 0 0,-1 0 0,1 0 0,5 0 0,0 0 0,-1 0 0,-6 0 0,0 0 0,1 0 0,6 0 0,1 0 0,0 0 0,-2 0 0,0 0 0,0 0 0,6 0 0,1 0 0,-3 0 0,-8 0 0,-1 0 0,1 0 0,5 0 0,1 0 0,-4 0 0,-7 0 0,-2 0 0,5 0 0,0 0 0,-1 0 0,-2 0 0,15 0 0,-7 0 0,1 0 0,-10 0 0,1 0 0,4 0 0,2 0 0,0 0-14,-2 0 0,-2 0 1,3 0 13,8 0 0,2 0 0,1 0-275,-10 0 0,1 0 1,-1 0-1,0 0 275,9 0 0,-1 0 0,0 0 0,-3 0 0,0 0 0,-1 0 0,-1 0 0,-1 0 0,-1 0-214,-2 0 0,0 0 1,0 0 213,3 0 0,1 0 0,1 0 0,-2 0 0,1 0 0,0 0 0,0 0 0,-1 0 0,2 0 0,4 0 0,1 0 0,0 0 0,-4 0 0,-2 0 0,2 0 0,4 0 0,0 0 0,-1 0 0,-4 0 0,-1 0 0,-1 0 0,-3 0 0,0 0 0,0 0 0,-1 0 0,1 0 0,-2 0 0,-1 0 0,0 0 0,8 0 0,-2 0 584,1 0-584,0 0 0,-1 0 1096,1 0-1096,-5 0 0,-2 0 701,4 0-701,-9 0 0,0 0 0,1 0 0,0 0 0,6 0 0,1 0 0,9 0 0,0 0 0,-2 0 0,1 0-276,-6 0 0,2 0 0,-1 0 276,-3 0 0,0 0 0,0 0 0,0 0 0,0 0 0,0 0-51,-1 0 1,0 0 0,-1 0 50,9 0 0,-1 0 0,-3 0 0,0 0 0,3 0 0,-1 0 0,-11 0 0,0 0 0,10 1 0,0-2 410,-7-5 1,0 0-411,8 5 0,3-1 0,-10-1 0,1-2 0,0 2-327,1 2 0,-1 1 1,2 1 326,8-1 0,1 0 0,1 0 0,-2-4 0,-1-1 0,2 2 0,-4 2 0,0 0 0,1 1 0,-3-1 0,1-3 0,-3-1 0,1 2 0,2 2 0,0 2 0,-2-1 0,2 1 0,-3-2 0,-5-8 0,0 0 0,8 8 0,-2-2 0,1-15 0,-1 11 0,1 3 0,0 1 569,-6-3 0,0 0-569,-2 6 0,0 0 0,1-9 0,0 0 0,8 7 0,1 0 0,-3-7 0,0 0 0,-4 8 0,0 1 0,0 1 0,8 0 0,1-2 0,-5-2 0,1-2 0,-2 1-299,6 3 1,-1 0 298,-4-3 0,0-1 0,0 2 0,4 2 0,1 2 0,-6-1 0,2 0 0,-2 0 0,3 0 0,0 0-41,-7 0 0,1 0 0,-1 0 41,6 0 0,-2 0 0,4 0 0,1 0 0,-4 0 0,0 0 0,-2 0 0,-3 0 0,3 0 593,1 0-593,-26 0 0,9 0 0,-12 0 0</inkml:trace>
+  <inkml:trace contextRef="#ctx0" brushRef="#br0" timeOffset="138716">4789 12052 24575,'26'0'0,"-4"0"0,1 0 0,13 0 0,-13 0 0,0 0 0,2 0 0,0 0 0,6 0 0,0 0 0,-1 0 0,1 0 0,-1 0 0,2 0 0,-7 0 0,-1 0 0,0 0 0,0 0 0,0 0 0,-4 0 0,-5 0 0,14 0 0,5 0 0,3 0 0,-6 0 0,0 0 0,-1 0 0,-8 0 0,0 0 0,11 0 0,-5 0 0,-9 0 0,0 0 0,9 0 0,-8 0 0,4 12 0,-21-10 0,26 10 0,-13-12 0,3-1 0,1 2 0,8 17 0,4-14 0,-10 5 0,0 0 0,9-9 0,-6-1 0,0 2 0,3 11 0,-9-11 0,0 1 0,9 9 0,4-11 0,1 0 0,-14 0 0,1 0 0,1 0 0,0 0 0,-1 0 0,-1 0 0,2 0 0,-9 0 0,-12 0 0,17 0 0,-12 0 0,24 0 0,-14 0 0,17 0 0,-13 0 0,2 0 0,4 0 0,3 0 0,1 0 0,2 0 0,-6 0 0,2 0 0,-1 0 0,8 0 0,1 0-175,-6 0 0,2 0 1,-1 0 174,-4 0 0,1 0 0,0 0-408,9 0 0,2 0 0,-1 0 408,-5 0 0,0 0 0,1 0 0,3 0 0,2 0 0,-2 0 0,-4 0 0,-2 0 0,1 0 0,-4 0 0,0 0 0,-1 0 0,1 0 0,0 0 0,-3 0 0,1 0 0,-1 0 0,7 0 0,-1 0 0,1 0 246,-5 0 0,-2 0-246,4 0 1256,5 0-1256,-1 0 0,-4 0 0,4 0 0,1 0 0,-6 0 0,-7 0 0,-1 0 0,9 0 0,4 0 0,0 0 0,-4 0 0,5 0 0,-1 0 0,-16 0 0,13 0 0,-8 0 0,7 0 0,4 0 0,-10 0 0,0 0 0,9 0 0,-6 0 0,0 0 0,3 0 0,-9 0 0,0 0 0,9 0 0,-7 0 0,2 0 0,-2 0 0,7 0 0,-7 0 0,8 0 0,-13 0 0,8 0 0,2 0 0,5 0 0,-9 0 0,0 0 0,10 0 0,-4 0 0,-9 0 0,1 0 0,7 0 0,6 0 0,-19 0 0,7 0 0,0 0 0,-2 0 0,5 0 0,2 0 0,2 0 0,-9 0 0,0 0 0,9 0 0,4-11 0,-17 8 0,-3-9 0,-12 12 0,0 0 0,0 12 0,0-9 0,-12 8 0,9-11 0,-9 0 0,12 0 0,0 0 0</inkml:trace>
+  <inkml:trace contextRef="#ctx0" brushRef="#br0" timeOffset="158049">12872 12025 24575,'0'-22'0,"12"5"0,15 14 0,7 6 0,-9-3 0,2 0 0,1 0-820,2 0 1,3 0 0,1 0 0,0 0 790,-2 0 0,-1 0 1,1 0-1,-1 0 29,-2 0 0,0 0 0,-1 0 0,1 0 0,1 0 0,1 0 0,0 0 0,-1 0 81,3 0 1,-2 0 0,0 0-82,0 0 0,0 0 0,0 0 0,-1 0 0,1 0 0,-2 0 0,5 0 0,1 0 217,-9 0 0,0 0 0,0 0-217,4 0 0,0 0 0,-3 1 0,-1-2 0,-6-5 0,-1 0 852,2 5 0,-3-1-852,-2-10 693,-16 12-693,-16 0 49,-2 0 1,-3 0-50,2 0 0,-1 0 0,-6 0 0,-1 0 0,-3 1 0,0-2 0,4-1 0,0-2 0,0-2 0,-9-4 0,1 0-185,4 5 1,-1 0 0,2-1 184,5-4 0,2-1 0,-1 2 0,-6 6 0,-2 4 0,1-2 0,3-2 0,1-2 0,-2 2 0,-6 2 0,-1 1 0,0 1 0,1-1 0,0 0 0,1 0 0,3 0 0,0 0 0,1 0 0,1 0 0,0 0 0,2 0 0,-5 1 0,2-2 0,4-8 0,1 0 0,-2 7 0,2 0 0,-4-16 0,8 18 0,-4 0 553,21 0-553,-8 0 0,11 0 0,0 0 0,0 18 0,0-14 0,11 14 0,-8-18 0,21 11 0,-4-8 0,8 9 0,-9-12 0,0 0 0,9 18 0,5-14 0,-12 5 0,2 0 0,6-9 0,2 0 0,-5 3 0,1 2 0,1-2-322,8-2 1,1-1-1,0 2 322,-4 5 0,-1 3 0,0-3 0,5-5 0,1-2 0,-3 1 0,-6 3 0,-2 0 0,-2 0 0,6-4 0,-1 0 0,-3 0 0,-4 0 0,-7 0 0,1 17 0,-17-12 0,0 12 0</inkml:trace>
+  <inkml:trace contextRef="#ctx0" brushRef="#br0" timeOffset="175966">9604 13216 24575,'24'0'0,"-1"0"0,6 0 0,0 0 0,-5 0 0,0 0 0,8 0 0,1 0 0,-3 0 0,0 0 0,3 0 0,0 0 0,-7 0 0,1 0 0,-2 0 0,6 0 0,1 0-327,-1 0 0,1 0 1,0 0 326,-7 0 0,0 0 0,1 0 0,9 0 0,3-1 0,-1 2-322,-9 1 1,0 2-1,1-1 1,-1 0 321,2-2 0,0-1 0,0 1 0,1 0 0,2 1 0,0 0 0,0 2 0,-1-1 0,5 3 0,0 1 0,-2-2 0,-7-3 0,-1-2 0,-2 2 0,8 8 0,-4-2 0,-1-8 0,-7 0 682,2 0-682,-20 0 396,9 0 0,-12 0 0,0 0 0</inkml:trace>
+  <inkml:trace contextRef="#ctx0" brushRef="#br0" timeOffset="178666">11298 13242 24575,'22'0'0,"1"0"0,3 0 0,1 0 0,8 0 0,2 0-1086,-6 0 0,2 0 1,2 0 1085,-5 0 0,1 0 0,2 0 0,-1 0 0,3 0 0,0 0 0,1 0 0,-1 0-404,1 0 1,1 0 0,-1 0 0,1 0 403,0 0 0,1 0 0,0 0 0,-1 0 0,-4 0 0,-1 0 0,0 0 0,0 0 1,1 0 1,0 0 0,0 0 0,-1 0-2,4 0 0,0 0 0,-2 0-11,-6 0 0,-1 0 1,-1 0 10,7 0 0,-2 0 705,-10 0 0,-2 0-705,0 0 0,0 0 2110,9 0-2110,4 0 333,-17 0 0,-3 0 1,-12 0-1</inkml:trace>
+  <inkml:trace contextRef="#ctx0" brushRef="#br0" timeOffset="212633">10014 13282 24575,'27'0'0,"-6"0"0,2 0 0,1 0 0,1 0 0,-2 0 0,2 0 0,7 0 0,-2 0 0,1 0 0,0 0 0,-1 0 0,-11 0 0,5 6 0,0 0 0,-8-3 0,4 9 0,4-12 0,-21 0 0,9 0 0,5 0 0,-12 0 0,24 17 0,-26-12 0,20 12 0,-20-17 0,27 0 0,-26 0 0,14 0 0,-18 0 0,0 0 0,12 0 0,-10 0 0,28 0 0,-14 0 0,5 0 0,2 0 0,-20 0 0,26 0 0,-24 0 0,13 0 0,-7 0 0,-8 0 0,9 0 0,0 0 0,-9 0 0,8 0 0,-11 0 0,0 0 0,0 0 0</inkml:trace>
+</inkml:ink>
+</file>
+
+<file path=ppt/ink/ink2.xml><?xml version="1.0" encoding="utf-8"?>
+<inkml:ink xmlns:inkml="http://www.w3.org/2003/InkML">
+  <inkml:definitions>
+    <inkml:context xml:id="ctx0">
+      <inkml:inkSource xml:id="inkSrc0">
+        <inkml:traceFormat>
+          <inkml:channel name="X" type="integer" min="-2.14748E9" max="2.14748E9" units="cm"/>
+          <inkml:channel name="Y" type="integer" min="-2.14748E9" max="2.14748E9" units="cm"/>
+          <inkml:channel name="F" type="integer" max="32767" units="dev"/>
+        </inkml:traceFormat>
+        <inkml:channelProperties>
+          <inkml:channelProperty channel="X" name="resolution" value="1000" units="1/cm"/>
+          <inkml:channelProperty channel="Y" name="resolution" value="1000" units="1/cm"/>
+          <inkml:channelProperty channel="F" name="resolution" value="0" units="1/dev"/>
+        </inkml:channelProperties>
+      </inkml:inkSource>
+      <inkml:timestamp xml:id="ts0" timeString="2026-03-18T20:00:58.937"/>
+    </inkml:context>
+    <inkml:brush xml:id="br0">
+      <inkml:brushProperty name="width" value="0.05292" units="cm"/>
+      <inkml:brushProperty name="height" value="0.05292" units="cm"/>
+      <inkml:brushProperty name="color" value="#FF0000"/>
+    </inkml:brush>
+  </inkml:definitions>
+  <inkml:trace contextRef="#ctx0" brushRef="#br0">1759 3559 24575,'0'32'0,"0"-16"0,0 14 0,0-28 0,0 22 0,0-21 0,0 26 0,0-1 0,0-2 0,0 1 0,0-2 0,0-1 0,0-1 0,0-1 0,0 11 0,0-19 0,0-2 0,0 6 0,0-2 0,0 7 0,0 4 0,0-3 0,0 0 0,0 1 0,0-1 0,0 0 0,0-4 0,0-5 0,0 14 0,0-13 0,0 3 0,0 0 0,0 9 0,0 5 0,0-1 0,0-12 0,0 0 0,0 0 0,0 1 0,0-1 0,0 0 0,0-1 0,0 0 0,0 1 0,0-1 0,0 2 0,0 0 0,0-1 0,0-1 0,0 2 0,0 2 0,0-20 0,0 9 0,0 6 0,0-14 0,0 14 0,0-6 0,0-9 0,18 8 0,-13-11 0,12 0 0,-17 18 0,0-14 0,0 14 0,0-18 0,12 0 0,-9 0 0,9 0 0,-12 0 0,11 0 0,-8 0 0,9 0 0,6 0 0,-14 0 0,26 0 0,-10 0 0,-4 0 0,14 0 0,-16 0 0,19 0 0,-14-9 0,1 0 0,0 7 0,2 0 0,6-7 0,1 0 0,8 9 0,-7 0 0,1 0 0,-10 0 0,1 0 0,4 0 0,2 0 0,0 0-224,-2 0 0,-1 0 0,1 0 224,6 0 0,1 0 0,0 0-409,2 0 1,-1 0-1,2 0 409,-8 0 0,0 0 0,1 0 0,-1 0 0,8 0 0,0 0 0,1 0 0,0 0 0,0 0 0,-1 0 0,-5 1 0,-1-1 0,1-1 0,6-2 0,0-2 0,0 2 0,-5 2 0,0 1 0,1-2 0,-3-4 0,0-3 0,2 0 0,-2 3 0,4 4 0,-1 1 0,1 0 0,-5-3 0,0-1 0,1 0 0,0 1 0,-1 3 0,0 1 0,1 1 0,1-1-623,5 0 1,1 0-1,1 0 1,1 0 622,-8 0 0,1 0 0,0 0 0,1 0 0,0 0-515,0 0 1,0 0-1,1 0 1,1 0-1,-1 0 1,0 0 514,0 0 0,-1 0 0,1 0 0,-1 0 0,1 0 0,0 0 0,1 0 0,1 0 0,0 0 0,-1 0 0,0 0 0,-1 0-218,1 0 0,-1 0 0,0 0 0,-1 0 0,0 0 218,0 0 0,0 0 0,-1 0 0,0 0 0,-1 0 0,0 0 0,-1 0 0,0 0 0,-1 0 57,0 0 1,0 0 0,-1 0 0,-1 0-58,5 0 0,-2 0 0,1 0 0,-1 0 0,0 0 0,-1 0 0,-1 0 0,-1 0 0,-1 0 0,1 0 0,0 0 0,0 0 0,3 0 0,0 0 0,0 0 0,-1 0 0,-1 0 0,2 0 0,4 0 0,1 0 0,1 0 236,-6 0 1,-1 0 0,1 0 0,0 0-237,0 0 0,0 0 0,0 0 0,1 0 400,1 0 0,1-1 0,0 1 0,0 1-400,0 3 0,0 1 0,0 0 0,0-1 0,3-2 0,0-2 0,1 1 0,0 0-20,-7 2 1,0 1-1,1 0 1,0-1-1,0 1 20,0-1 0,1-1 0,0 1 0,-1-1 0,1 0 0,0-1 0,0-1 0,0 0 0,0 0 0,-1 2 0,6 0 0,0 2 0,-1-1 0,1-1 0,0-1 0,1-2 0,0 0 0,-1 2 0,0 3 0,-1 1 0,0 0 0,0-1 0,0-2 0,-1-2 0,0 1 0,1 0-186,-2 3 0,1 1 0,-1 0 0,1-1 186,-2-1 0,0 1 0,0-1 0,-1-1-26,4-1 0,0-1 0,0 2 26,-4 0 0,1 2 0,-1-1 0,-1-1 0,2-1 0,-1-1 0,0-1 0,-2 1 0,1 0 0,0 0 0,-1 0 0,2 0 0,-1 0 0,2 0 0,-3 0 0,1 0 0,0 0 0,-1 0 0,3 0 0,-1 0 0,0 0 304,1 0 0,0 0 0,-1 0-304,-4 0 0,-2 0 0,-2 0 999,1 0 0,-1 0-999,-2 0 0,0 0 1700,10 0-1700,-13 0 0,2 0 0,4 0 0,3 0 0,7 0 0,2 0 244,-11 0 1,1 0 0,1 0-245,4 0 0,1 0 0,0 0 0,-1 0 0,-1 0 0,0 0 0,2 0 0,0 0 0,0 0 0,-6 0 0,0 0 0,-1 0 0,11 0 0,-2 0 326,-7 0 1,-3 0-327,-5 0 0,0 0 0,5 0 0,0 0 0,-1 6 0,1 0 0,4-4 0,2-1 0,-5 3 0,2 1 0,0-2-224,-3-2 1,0-2 0,2 1 223,4 0 0,3 0 0,-1 0 0,1 0 0,1 0 0,0 0-147,-7 0 1,1 0 0,-1 0 0,1 0 146,7 0 0,0 0 0,0 0 0,1 0 0,1 0 0,-2 0 0,-5 0 0,0 0 0,-1 0-170,-3 0 1,0 0 0,0 0 169,3 0 0,0 1 0,0-2 0,-3-3 0,-1 0 0,2 0 0,2 3 0,1 1 0,0-2-327,-4-2 0,1-2 0,0-1 1,-1 1 326,6-2 0,-2 1 0,2 1 0,-1 2 0,1 1 0,0-1 0,-3-1 81,-2-5 0,-2-1 0,0 3-81,2 5 0,1 4 0,-4-2 581,-4-6 0,-2 2-581,0 4 0,0 2 511,9-1-511,4 0 1457,1 0-1457,-6-18 407,6 14-407,-18-14 0,-4 18 0,-11-12 0,0 9 0,-11-8 0,-4-1 0,0-9 0,0 8 0,1-2 0,-2-17 0,5 16 0,1 0 0,-2-6 0,0-2 0,2 1 0,0-2 0,4 1 0,1-2 0,0-1 0,-1-3 0,-1 0 0,2-2-403,1 4 0,1-1 1,0 0-1,1 0 403,1-2 0,1-1 0,-1 0 0,0 1 0,-1-2 0,-2 0 0,1 0 0,1 1 0,1-5 0,1 1 0,1 0 0,-1 5 0,0 0 0,0 0 0,0 2-197,0 0 1,0 2 0,0-1 196,0-6 0,0-1 0,0 3 0,0-4 0,0 3 0,0 2 0,0 1 0,0 4 0,0 2 0,0-4 0,0 8 1560,0-4-1560,0 21 640,0-26-640,0 13 0,0-16 0,0 17 0,0 3 0,-18 24 0,2 3 0,-17-1 0,18 1 0,-2 0 0,-2-7 0,-2 0 0,1 7 0,-1 2 0,-8 0 0,1-2 0,9 0 0,1-2 0,-4-1 0,0-3 0,-10 3 0,4-12 0,9 0 0,0 0 0,-1 0 0,0 0 0,-5-1 0,-3 2 0,0 4 0,-3 2 0,0-2-384,0-3 1,-2-1-1,0 1 384,5 2 0,0 1 0,-1 0 0,1-2 0,-4-1 0,2-3 0,0 0 0,2 1 0,2 0 0,2 0 0,-1 0 0,1 0 0,2 0 0,0 0 0,-10 0 0,4 0 0,4 0 0,-2 0 575,2 0 1,-1 0-576,-7 0 0,-2 0 0,8 0 0,0 0 0,0 0 0,-5 0 0,-1 0 0,6 0 0,0 0 0,2 0 0,-1 0 0,1 0 0,-4 0 0,-1 0 0,2 0 0,1 0 0,5 0 0,-1 0 0,-8 0 0,-2 0 0,8 0 0,0 0 0,-9 0 0,0 0 0,8 0 0,1 0 0,-7 0 0,1 0 0,-1 0 0,0 0 0,0 0 0,0 0 0,6 0 0,0 0 0,-3 0 0,9 0 0,0 0 0,-9 0 0,-2-8 0,-2-1 0,7 6 0,-1 1-215,-6-3 1,-4-2-1,2 2 215,-2 4 0,0 2 0,3-5 0,-1 0 0,0 0 0,6 3 0,2 0 0,-1 0 0,0-3 0,1 0 0,-2 0 0,-1 3 0,-2 2 0,2-1 0,1 0 0,2 0 0,-1 0 0,0 0 0,0 0 0,0 0 0,-3 0 0,-1 0 0,2 0 0,0 0 0,1 0 0,-7 0 0,1 0 0,13 0 0,1 0 0,0 0 0,0 0 0,1 0 0,0 0 0,-9 0 644,-4 0-644,17 0 0,-15 0 0,14 0 0,-16 0 0,0 0 0,4 0 0,3 0 0,0 0 0,-6 0 0,6 0 0,0 0 0,5 0 0,0 0 0,0 0 0,-1 0 0,1 0 0,0 0 0,1 0 0,0 0 0,0 0 0,-2 0 0,-5 0 0,0 0 0,1 0 0,1 0 0,-4 0 0,-1 0 0,2 0 0,1 0 0,4 0 0,1 0 0,-4 0 0,0 0 0,2 0 0,1 0 0,-15 0 0,15 0 0,0 0 0,0 0 0,0 0 0,-2 0 0,-1 0 0,1 0 0,0 0 0,-2 0 0,2 0 0,4 0 0,0 0 0,-1 0 0,1 0 0,0 0 0,0 0 0,-5 0 0,0 0 0,1 0 0,0 0 0,-6 0 0,-1 0 0,-1 0 0,0 0 0,2 0 0,-1 0 0,-2 0 0,0 0 0,4 0 0,-2 0 0,4 0 0,-1 0 0,1 0 0,-2 0 0,-1 0 0,-1 0 0,-2 0 0,3 0 0,3 0 0,2 0 0,-4 0 0,1 0 0,8 0 0,2 0 0,-10 0 0,3 0 0,0 0 0,-6 0 0,10 0 0,-2 0 0,1 0 0,0 0 0,-2 0 0,-1 0 0,1 0 0,0 0 0,-2 0 0,2 0 0,-4 0 0,9 0 0,0 0 0,-9 0 0,-5 0 0,1 0 0,4 0 0,-4 0 0,0 0 0,4 0 0,9 0 0,-1 0 0,-8 0 0,-4 0 0,10 0 0,0 0 0,-9 0 0,5 0 0,2 0 0,8 0 0,-13 0 0,8 0 0,-7 0 0,-4 0 0,-1 0 0,6 0 0,-6 0 0,1-17 0,4 12 0,9-4 0,0 1 0,-9 8 0,-5-12 0,12 10 0,-2 1 0,0-5 0,-2 0 0,-8 0 0,0 0 0,2 5 0,1-1 0,3-4 0,1 1 0,6 4 0,1 2 0,-1-1 0,2 0 0,-10 0 0,-5 0 0,1 0 0,4 0 0,-4 0 0,10 0 0,0 0 0,-15 0 0,8 0 0,1 0 0,6 0 0,2 0 0,1 0 0,-1 0 0,-5 0 0,0 0 0,0 0 0,1 0 0,0 0 0,0 0 0,1 0 0,2 0 0,-12 0 0,17 0 0,-13 0 0,14 0 0,-17 11 0,4-8 0,9 4 0,0-2 0,-9-5 0,-5 0 0,1 0 0,4 0 0,8 6 0,2 0 0,2-3 0,-14 9 0,-2-12 0,1 17 0,1-15 0,-2 1 0,8 11 0,0 1 0,-6-13 0,-1-1 0,-2 14 0,2-1 0,10-11 0,-1-1 0,-9 7 0,0-1 0,-5-8 0,7 0 0,0 0 0,9 6 0,-1 0 0,-5-4 0,1-1 0,3 5 0,3 0 0,-9-6 0,-2 0 0,10 0 0,4 12 0,-14-9 0,27 8 0,-20-11 0,20 0 0,-9 0 0,-6 0 0,14 0 0,-25 0 0,26 0 0,-27 18 0,26-14 0,-14 14 0,6-18 0,9 0 0,-8 0 0,-1 0 0,9 0 0,-9 0 0,-5 0 0,0 0 0,-3 0 0,-4 0 0,21 0 0,-26 0 0,13 0 0,-3 0 0,0 0 0,2 0 0,-12 0 0,14 0 0,1 0 0,-16 0 0,26 0 0,-26 0 0,27 0 0,-20 0 0,20 0 0,-26 0 0,24 0 0,-24 0 0,8 0 0,-7 0 0,8 0 0,-4 0 0,21 0 0,-26 0 0,13 0 0,-5 0 0,-2 0 0,2 0 0,-7 0 0,9 0 0,0 0 0,-9 0 0,-4 0 0,-1 0 0,10 0 0,1 0 0,-3 0 0,3 0 0,3 0 0,4 0 0,0 0 0,3 0 0,-5 0 0,12 0 0,-12 0 0,17 0 0,0-18 0,0 2 0,0-4 0,0 8 0</inkml:trace>
+</inkml:ink>
+</file>
+
+<file path=ppt/ink/ink3.xml><?xml version="1.0" encoding="utf-8"?>
+<inkml:ink xmlns:inkml="http://www.w3.org/2003/InkML">
+  <inkml:definitions>
+    <inkml:context xml:id="ctx0">
+      <inkml:inkSource xml:id="inkSrc0">
+        <inkml:traceFormat>
+          <inkml:channel name="X" type="integer" min="-2.14748E9" max="2.14748E9" units="cm"/>
+          <inkml:channel name="Y" type="integer" min="-2.14748E9" max="2.14748E9" units="cm"/>
+          <inkml:channel name="F" type="integer" max="32767" units="dev"/>
+        </inkml:traceFormat>
+        <inkml:channelProperties>
+          <inkml:channelProperty channel="X" name="resolution" value="1000" units="1/cm"/>
+          <inkml:channelProperty channel="Y" name="resolution" value="1000" units="1/cm"/>
+          <inkml:channelProperty channel="F" name="resolution" value="0" units="1/dev"/>
+        </inkml:channelProperties>
+      </inkml:inkSource>
+      <inkml:timestamp xml:id="ts0" timeString="2026-03-18T20:08:33.968"/>
+    </inkml:context>
+    <inkml:brush xml:id="br0">
+      <inkml:brushProperty name="width" value="0.05292" units="cm"/>
+      <inkml:brushProperty name="height" value="0.05292" units="cm"/>
+      <inkml:brushProperty name="color" value="#FF0000"/>
+    </inkml:brush>
+  </inkml:definitions>
+  <inkml:trace contextRef="#ctx0" brushRef="#br0">939 1574 24575,'26'0'0,"0"0"0,-3 0 0,2 0 0,5 0 0,2 0 0,0 0-713,-5 0 0,-2 0 1,3 0 712,1 0 0,2 0 0,0 0 0,0 0 0,3 0 0,-1 0 0,1 0 0,2 0 0,0 0 0,-2 0-41,-7 0 0,0 0 0,0 0 41,4 0 0,2 0 0,-3 0 0,-1 0 0,1 0 0,1 0 0,4 0 0,-1 0 0,-5 0 0,0 0 0,1 0 0,3 0 0,0 0 0,2 0-162,-5 0 0,1 0 0,0 0 0,-1 0 162,3 0 0,-1 0 0,0 0 0,5 0 0,0 0 0,-1 0 0,-4 0 0,-1 0 0,-1 0-232,1 0 1,0 0 0,0 0 231,0 1 0,0-1 0,-1-1 0,-2-2 0,-1-2 0,-1 2 478,8 1 0,-2 1-478,-2-6 0,-2 2 295,-8 4 1,1 2-296,5 0 0,-1-2 623,-4-8 0,-1 0-623,9 7 0,0 0 405,-11-7 0,0 0-405,13 8 0,0 2 0,-10-1 0,1 0 0,3 0 0,4 0 0,-1 0 0,-2 0 0,-1 0 0,1 0 0,0 0 0,2 0 0,-2 0 0,0 0 0,0 0 0,-1 0 0,11 0 0,0 0 0,-2 0 0,1 0-270,-6 0 1,2 0 0,-1 0 269,-3 0 0,-1 0 0,1 0 0,6 1 0,1-1 0,-2-1 0,1-5 0,-1 0 0,-6 5 0,2 1 0,-3-2 0,-3-4 0,-1 1 0,5 4 0,1 2 0,3-1 0,-3 0 0,-2 0 0,-2 0 0,-5 0 808,-15 0-808,9 0 0,-12 0 0,0 0 0</inkml:trace>
+  <inkml:trace contextRef="#ctx0" brushRef="#br0" timeOffset="1083">4313 1482 24575,'22'0'0,"0"0"0,6 0 0,4 0 0,-1 0 0,2 0 0,2 0-777,-5 0 1,2 0 0,0 0 0,0 0 776,-2 0 0,-1 0 0,1 0 0,-1 0 0,8 0 0,1 0 0,-3 0 489,2 0 1,-2 0-490,-7 0 0,-3 0 510,3 0-510,-11 0 0,-17 0 0,0 0 0</inkml:trace>
+  <inkml:trace contextRef="#ctx0" brushRef="#br0" timeOffset="7617">4564 5133 24575,'34'0'0,"1"0"0,-1 0 0,-5 0 0,0 0 0,2 0 0,2 0 0,2 0 0,-3 0 0,2 0 0,1 0 0,2 0 0,0 0 0,1 0 0,1 0 0,-1 0-328,-5 0 0,1 0 0,0 0 1,0 0-1,1 0 0,0 0 1,1 0-1,-1 0 0,1 0 1,0 0 29,0 0 0,1 0 0,0 0 0,0 0 0,0 0 0,1 0 0,0 0 0,-1 0 1,1 0-1,0 0 0,-1 0 24,-2 0 1,-1 0 0,0 0 0,1 0 0,-1 0 0,0 0 0,1 0 0,-1 0 0,1 0 0,-1 0 0,1 0 0,-1 0-1,1 0 1,1 0 0,-1 0 0,1 0 0,0 0 0,-1 0 0,1 0 0,-1 0 0,0 0 0,0 0 0,-1 0 0,0 0 185,3 0 1,-1 0-1,-1 0 1,1 0-1,-1 0 1,0 0 0,-1 0-1,1 0 1,-1 0-1,0 0 88,3 0 0,0 0 0,0 0 0,0 0 0,0 0 0,-1 0 0,-1 0 0,0 0 0,-1 0-185,4 0 0,-1 0 0,-1 0 0,0 0 0,-1 0 0,0 0 0,0 0 185,2 0 0,0 0 0,-1 0 0,0 0 0,0 0 0,1 0 0,0 0 0,0 0 0,0 0 0,0 0 0,0 0 0,-2 0 275,2 0 1,-2 0 0,0 0 0,0 0 0,1 0-276,-3 0 0,1 0 0,0 0 0,-1 0 0,1 0 0,-2 0 0,1 0 0,0 0 0,-2 0 0,1 0 0,1 0 432,1 0 1,0 0 0,1 0 0,-1 0 0,-1 0-433,3 0 0,-1 0 0,0 0 0,0 0 0,-2 0 0,0 0 0,1 0 0,0 0 0,-2 0 0,5 0 0,-2 0 0,1 0 0,0 0 0,-3 0 0,1 0 0,0 0 0,1 0 0,0 0 236,-4 0 1,0 0-1,0 0 1,1 0-1,-1 0 1,1 0-237,0 0 0,1 0 0,-1 0 0,0 0 0,1 0 0,1 0 0,1 0 0,2 0 0,-1 0 0,1 0 0,0 0 0,0 0-39,0 0 0,0 1 1,0-1-1,0 0 1,0 0-1,1-1 39,-4-1 0,0 0 0,1-1 0,-1 0 0,1 0 0,0 0 0,1 1-181,-3 1 0,0 1 0,1 0 1,0 0-1,0 0 0,1-1 1,-1 0-1,0 0 181,2-2 0,0 0 0,0-1 0,0 0 0,0 0 0,0-1 0,1 2 0,-1-1 0,-1 2 0,1 0 0,0 0 0,0 0 0,-1 1 0,1-1 0,0 1 0,-1-1-84,-1 0 1,0 1-1,0-1 1,0 1-1,0-1 1,0 0-1,-2 0 1,1-1 83,5-1 0,0-2 0,-1 1 0,-1-1 0,0 1 0,1 2 0,-3 1 0,1 1 0,-1 1 0,0 0 0,0 0 0,-2-2 0,0-1 0,-1-1 0,-1 0 0,0 0 0,-1 2 248,4 1 0,-2 1 0,0 0 0,-1 1-248,8-1 0,-2 0 0,1 0 0,-2 0 0,0 0 0,0 0 0,-5 0 0,0 0 0,0 0 0,0 0 0,6 0 0,0 0 0,0 0 0,1 0 0,0 0 0,0 0 696,-6 0 0,0 0 0,-1 0-696,1 0 0,0 0 0,0 0 0,0 0 0,0 0 0,-1 0 0,-2 0 0,-1 0 0,-1 0 0,1 0 0,0 0 0,-3 0 819,13 0 0,-8 0 0,-29 0 0</inkml:trace>
+  <inkml:trace contextRef="#ctx0" brushRef="#br0" timeOffset="12983">4405 4934 24575,'22'0'0,"0"0"0,8 0 0,5 0 0,2 0 0,-2 0 0,1 0 0,3 0 0,1 0-547,-6 0 1,1 0 0,2 0 0,0 0 0,1 0 0,0 0 77,-3 0 1,2 0 0,-1 0 0,1 0 0,1 0 0,-1 0 0,0 0 250,-4 0 1,1 0 0,-1 0 0,1 0-1,-1 0 1,1 0 0,-1 0 0,1 0 217,3 0 0,1 0 0,0 0 0,0 0 0,-1 0 0,-1 0 0,0 0 0,-1 0 0,0 0 0,-1 0 0,-1 0 0,-1 0 0,0 0 460,1 0 0,0 0 1,-2 0-1,-1 0 1,-3 0-461,3 0 0,-3 0 0,-3 0 654,0 0 1,-2 0-655,-2 0 0,1 0 0,9 0 0,5 0-722,-3 1 1,5 0 0,3-1 0,1-2 721,-9 0 0,2-1 0,1-1 0,1-1 0,0 1 0,1-1 23,-2 1 0,1-1 0,1 0 0,-1 0 1,1 0-1,0-1 0,-1 1-23,-1-1 0,0 1 0,0-1 0,0 0 0,-1 0 0,0-1 0,-2 0 0,5-3 0,0-1 0,-2 0 0,-1 1 0,-2 2 0,8 2 0,-2 2 0,-6-2 0,-7-6 0,-6 6 0,-7 24 0,-12-14 0,0 14 0,0-18 0</inkml:trace>
+  <inkml:trace contextRef="#ctx0" brushRef="#br0" timeOffset="14034">9763 4789 24575,'35'0'0,"1"0"0,-1 0 0,0 0 0,-5 0 0,1 0 0,2 0 0,1 0 0,1 0 0,2 0 0,0 0 0,1 0-274,-4 0 1,0 0 0,1 0 0,1 0 0,1 0 0,1 0 0,0 0 0,1 0 0,0 0 0,1 0 0,0 0 0,0 0 68,-5 0 0,1 0 0,0 0 0,1 0 1,0 0-1,0 0 0,1 0 0,0 0 0,1 0 1,-1 0-1,0 0 0,1 0 0,-1 0 0,0 0 1,0 0-1,0 0 0,-1 0 0,1 0 0,0 0 0,0 0 1,-1 0-1,1 0 0,0 0 0,0 0 0,0 0 1,0 0-1,-1 0 0,0 0 0,1 0 0,-2 0 1,1 0-1,-1 0-30,3 0 1,-1 0 0,0 0 0,0 0 0,0 0 0,0 0 0,0 0 0,-1 0 0,0 0 0,-1 0 0,1 0 0,-2 0 0,1 0 0,-2 0 180,4 0 1,0 0 0,-1 0 0,0 0 0,0 0 0,-2 0 0,1 0 0,-2 0 0,0 0 0,-1 0 0,-1 0 53,7 0 0,-1 0 0,-1 0 0,-1 0 0,-1 0 0,-1 0 0,-1 0-80,4 0 1,-1 0 0,-2 0 0,-1 0 0,-3 0 79,4 0 0,-3 0 0,-3 0 1583,-5 0 0,-2 0-1583,8 0 0,-24 0 0,12 0 0</inkml:trace>
+  <inkml:trace contextRef="#ctx0" brushRef="#br0" timeOffset="42100">4432 7990 24575,'31'0'0,"1"0"0,-2 0 0,5 0 0,1 0 0,3 0 0,-7 0 0,1 0 0,2 0 0,1 0 0,0 0 0,2 0-410,-4 0 0,1 0 1,1 0-1,0 0 1,1 0-1,0 0 0,0 0 1,-1 0-1,0 0 0,0 0 1,0 0-1,0 0 1,0 0-1,0 0 0,0 0 1,0 0 51,-1 1 1,1-1 0,0 0 0,-1 0-1,1 0 1,-2 0 0,1 0 0,-1-1 262,0 0 1,1 0-1,-2 0 1,1-1-1,-2 0 1,1 0 0,-1 0 94,4-1 0,-1-1 0,-1 1 0,1-1 0,-2 0 0,0 1 184,3 0 0,0 1 0,-2-1 0,0 0 1,-3-2-185,-2-2 0,-1-2 0,-2 1 0,0 3 0,3 3 0,-1 2 0,-3-1 0,-4-6 0,-2 2 3276,1 5-2471,10 0 2471,-26 0-3140,14 0 1523,-7 0-1659,4 0 0,17-12 0,-4 9 0,-7-9 0,-9 12 0,-12 0 0,0 0 0</inkml:trace>
+</inkml:ink>
+</file>
+
+<file path=ppt/ink/ink4.xml><?xml version="1.0" encoding="utf-8"?>
+<inkml:ink xmlns:inkml="http://www.w3.org/2003/InkML">
+  <inkml:definitions>
+    <inkml:context xml:id="ctx0">
+      <inkml:inkSource xml:id="inkSrc0">
+        <inkml:traceFormat>
+          <inkml:channel name="X" type="integer" min="-2.14748E9" max="2.14748E9" units="cm"/>
+          <inkml:channel name="Y" type="integer" min="-2.14748E9" max="2.14748E9" units="cm"/>
+          <inkml:channel name="F" type="integer" max="32767" units="dev"/>
+        </inkml:traceFormat>
+        <inkml:channelProperties>
+          <inkml:channelProperty channel="X" name="resolution" value="1000" units="1/cm"/>
+          <inkml:channelProperty channel="Y" name="resolution" value="1000" units="1/cm"/>
+          <inkml:channelProperty channel="F" name="resolution" value="0" units="1/dev"/>
+        </inkml:channelProperties>
+      </inkml:inkSource>
+      <inkml:timestamp xml:id="ts0" timeString="2026-03-18T20:09:33.835"/>
+    </inkml:context>
+    <inkml:brush xml:id="br0">
+      <inkml:brushProperty name="width" value="0.05292" units="cm"/>
+      <inkml:brushProperty name="height" value="0.05292" units="cm"/>
+      <inkml:brushProperty name="color" value="#FF0000"/>
+    </inkml:brush>
+  </inkml:definitions>
+  <inkml:trace contextRef="#ctx0" brushRef="#br0">2924 2580 24575,'0'22'0,"0"0"0,0 1 0,0 2 0,0 0 0,0 1 0,0 1-443,0 0 1,0 0 0,0 0 442,-1 3 0,0 1 0,3 1 0,3 1 0,2 0 0,-2-1 0,-3-6 0,-2-1 0,3 1 0,5 5 0,3 1 0,-1-1 0,-3 0 0,1 1 0,2-3 0,2 2 0,-2-1 0,-1 4 0,-2 1 28,-1-10 1,0 2-1,0-1-28,1 7 0,-2 0 151,-4-3 1,1 0-152,3 2 0,1 1 0,4-3 0,-2 0 0,-6-6 0,0 0 0,8 8 0,-2-2 666,-8 1-666,6 0 0,0 0 273,-3 0-273,3 0 0,0-1 0,-6-11 0,0 7 0,0-5 0,0-16 0,0 13 0,11-18 0,-8 0 0,9 0 0,6 0 0,-14 0 0,25 0 0,4 0 0,-5 0 0,4 0 0,-3 0 0,2 0 0,2 0-547,-6 0 1,1 0 0,0 0 0,2 0 546,3 0 0,2 0 0,0 0 0,0 0 0,1 0 0,0 0 0,1 0 0,1 0 0,-3 0 0,2 0 0,0 0 0,0 0 0,-1 0-539,-3 0 1,0 0 0,-1 0 0,1 0 0,1 0 538,-2 0 0,2 0 0,0 1 0,0-1 0,0 0 0,-2-1 0,0-2 0,-1-1 0,0 0 0,0 0 0,1 1 0,-1 1 0,1 2 0,1 0 0,0-1 0,-1 1 0,0-2 0,2 0 0,0-2 0,-1 0 0,0 0 0,2 1 0,-4 0 0,0 1 0,1 0 0,0 0 0,0 0 0,1 1 0,0 0 0,1 1 0,0 1 0,0-1 0,0-1 0,0-1-443,-2-1 0,-1-2 0,0-1 0,1 0 0,-1 1 0,1 1 443,3 0 0,-1 1 0,2 1 0,-1 0 0,0-1 0,-1 1 0,-2-2 0,-1 1 0,0 0 0,0-1 0,0 1 0,0-1 0,0 0 0,1 0 0,0-1 0,0 1 0,0 0 0,0 1 0,5 2 0,0 1 0,0 1 0,0-2 0,0 0 0,-5-3 0,0-1 0,0-1 0,0 0 0,0 1 0,-1 1-299,4 2 1,1 2-1,-1 0 1,-1 0-1,1-2 299,-1-3 0,1-2 0,-1 0 0,0 1 0,-1 1 0,5 3 0,-2 2 0,0 0 0,0-1 0,-2-1 0,-1-1 0,-1 0 0,1 0 76,0-1 1,0 1 0,0 0-1,-1 1-76,-2 1 0,0 1 0,0 0 0,1-2 0,1-4 0,0-3 0,1 1 0,0 2 0,2 3 0,-1 3 0,1 0 0,0-2 91,1-4 1,0-3-1,1 1 1,1 2-92,-7 4 0,1 2 0,0 0 0,0 1 0,-1-3 0,1-3 0,0-1 0,0-1 0,0 1 0,-1 0 0,0 2 0,-1 1 0,1 0 0,-1 0 0,1 0 0,0-1 0,1 0 0,-1 0 0,1 0 0,-1 0 0,0-1 0,-1-1 0,1 1 0,-1 1 0,1 0 0,1 2 0,-1 2 0,1 0 0,0 0 0,0-1 0,0-1 0,0-1 0,0 1 0,0-1 0,-1 1 0,2 2 0,-1 0 0,0 0 0,0 0 267,3 0 0,1 0 0,-1 0 0,-1 0-267,3 0 0,-2 0 0,1 0 199,-7 0 1,-1 0 0,0 0 0,1 0-200,8 0 0,-1 0 0,1 0 0,-2 0 0,0 0 0,1 0 0,-5 0 0,2 0 0,0 0 0,0 0-115,2 0 0,0 0 1,1 0-1,0 0 115,-5 0 0,0 0 0,1 0 0,0 0 0,0 0 0,2 0 0,1 0 0,-1 0 0,0 0 0,0 0 0,4 0 0,-1 0 0,0 0 0,1 0 0,-6 2 0,0 1 0,0 0 0,1-1 0,-1 0-148,3-1 1,0-1 0,0 0 0,0 0 0,0 2 147,-4 1 0,1 1 0,-1 1 0,1 0 0,0-1 0,0-1 0,2-2 0,0-1 0,0 0 0,1 0 0,0 0 0,0 2-268,-1 1 0,0 1 0,1 1 0,0 0 0,1 0 0,-1-1 0,0-1 268,1-1 0,0-2 0,0 0 0,1 0 0,-1 0 0,1 1 0,0 0 0,-4 2 0,1 1 0,-1 0 0,1 0 0,0 1 0,0-1 0,0-1 0,0 0 0,0-2 0,0 0 0,0-1 0,0 0 0,-1 0 0,1 0 0,-1 0 0,0 1 0,2 0 0,-1 1 0,0 0 0,0 0 0,0 0 0,-1-1 0,0 0-191,2 0 0,0-1 0,0-1 0,-1 0 1,0 2-1,0-1 191,-2 2 0,0 1 0,0 0 0,0 1 0,-1-1 0,1 0 0,0 0 0,1-1 0,-1 0 0,0 1 0,1 0 0,-1 0 0,0 2 0,1 0 0,-1 0 0,0 1 0,1 0 0,-1 0 0,1-1 0,1 1 0,-1 0 0,0-1 0,1 1 0,0-2 0,3 0 0,-1-2 0,1 0 0,0 0 0,0 1 0,0 0-208,-1 1 1,0 1-1,1 0 1,-1 0-1,1 0 1,0 1 207,-2-2 0,0 1 0,1-1 0,0 1 0,0 0 0,0-1 0,1 1-138,-2-1 1,0-1-1,0 0 1,1 0-1,0 0 1,0 1-1,-1 1 1,1 1 137,0 1 0,0 2 0,0 0 0,0 1 0,0 0 0,0 0 0,0 0 0,0-2 0,-3-1 0,0-1 0,0-1 0,1 1 0,-1-1 0,0 0 0,0 0 0,0 1 0,-1 1 0,2 0 0,-1 1 0,0 0 0,0 1 0,-1 0 0,0-1 0,0 1 0,-1-1 108,2 0 1,-1 1 0,0-1 0,-1 1 0,0-1 0,-1 0-1,0-1-108,6 2 0,-1 0 0,-1-1 0,0 0 0,-2-1 270,1 1 0,-1-1 0,-2 0 0,0-1-270,2 1 0,-2 0 0,0-3 902,-3-3 0,0-2 0,-3 1-902,2 0 0,-3 0 3276,9 0-1994,-20 0 1649,-12 0-2931,0-18 1013,0 2-1013,0-5 0,-4 1 0,-4-1 0,-13 2 0,9-11 0,-3-2 0,-10 17 0,0 0 0,9-16 0,1 0 0,-11 13 0,2-1 0,12-3 0,4-5 0,0 1-454,-3 4 1,0 0-1,0-3 454,0-2 0,-1-3 0,1-2 0,1-1-656,3 1 1,2-2-1,0 0 1,-1-1 0,-2 0 641,0 3 0,-3 1 0,0-1 0,-1 0 0,2 0 0,1-2 14,2 2 0,2-2 0,0 0 0,1-1 0,0 1 0,-2 0 0,0 2 0,-2-1 0,-2 1 0,0 0 0,0 1 0,0 0 0,1 0 0,0-4 0,0-1 0,1 1 0,0 2 0,0 2-48,-1-6 1,-1 4-1,2 1 48,-1-6 0,0 7 0,-3 11 0,9-10 1111,-9 26-1111,12-14 3276,0 18-2984,-11 0-106,8 0-186,-27-12 0,14-2 0,-4-1 0,4-1 0,2 3 0,10 8 0,-26-12 0,27 17 0,-20 0 0,-9-12 0,14 6 0,-1-3 0,-9-12 0,-1-2 0,2 5 0,1-1 0,6 4 0,0 0 0,-1 0-262,-4-3 0,-1 1 0,-1 2 262,1 3 0,-1 3 0,0-1 0,-3-5 0,-1 0 0,-1 1-315,5 5 0,-1 0 0,0 2 1,1-1 314,-6-1 0,1 0 0,0-1 0,4 1 0,0-1 0,0 0 0,2 1-184,-2 3 1,1 2-1,1-2 184,-4-4 0,-1-1 0,2 3 0,-6 6 0,1 1 0,4-5 0,0 0 0,-2 0 0,2 0 714,-1 3-714,1-11 0,-2-1 0,8 12 0,0 1 635,-6-7 0,0 1-635,-2 7 0,-1 2 0,-3-1 0,0 0 0,2 0 0,-1 0 0,5 0 0,0 0 0,0 0 0,-5 0 0,1 0 306,4 0 0,0 0-306,-2 0 0,2 0 0,6 0 0,-1 0 0,-8 0 0,0 0 0,9 0 0,0 0 0,-7 0 0,0 0 0,7 0 0,0 0 0,-6 0 0,-1 0 0,-2 0 0,2 0 0,9 0 0,1 0 0,-5 0 0,2 0 0,8 0 0,-14 0 0,28 0 0,-28 0 0,14 0 0,-12 0 0,-6 0 0,9-1 0,-1 1 0,-4 1-627,4 1 1,-4 2 0,0 0 0,-2 0 0,0-1 626,-3 1 0,0-1 0,-2-1 0,0 2 0,-1 0-528,3 0 0,-1 2 0,-1 0 0,0 0 1,0-1-1,0 0 528,1-2 0,-1 0 0,0 0 0,1-1 0,-1 0 0,1 0 0,1 0 0,0 0 0,1 0 0,-1 1 0,2-2 0,-1 0 0,-2 0 0,1-1 0,0 0 0,1 0 0,1-1-241,-3 1 0,0 0 0,2 0 0,2 0 241,-2 0 0,1 0 0,1 0-147,2 0 1,0 0-1,1 0 147,2 0 0,0 0 0,0 0 0,-4 0 0,0 0 0,0 0 0,0 0 0,1 0 0,-1 0 0,-2 0 0,0 0 0,0 0 0,1 0 0,1 0 0,0 0 0,3 0 0,2 0 0,-1 0 747,1 0 1,0 0 0,2 0-748,-7 0 0,1 0 1638,6 0 0,0 0-1599,-3 0 1,4 0 1299,7 0-1339,-2 0 679,6 0-679,-8 0 0,2 0 0,-4 0 0,-3 0 0,-2 0 0,-3 0-589,2 0 0,-2 0 0,0 0 1,-3 0 588,0 0 0,-2 0 0,-2 0 0,0 0 0,0 0-547,4 0 1,0 0 0,-1 0 0,0 0 0,1 0 0,-1 0 514,-2 0 1,1 0 0,-1 0 0,0 0 0,1 0 0,1 0 31,-1 0 0,0 0 0,2 0 0,-1 0 0,2 0-203,-5 0 0,0 0 1,1 0-1,3 0 203,0 0 0,2 0 0,3 0 0,2 0 0,3 0 0,1 0 0,3 0 1863,-2 0-1863,1 0 0,-5 0 0,1 0 0,-2 0 0,-2 0 382,-1 0 0,-2 0 0,-1 0 0,-1 0-382,2 0 0,-1 0 0,-1 0 0,0 0 0,0 0 0,-1 0 0,-2 0 0,1 0 0,0 0 0,0 0 0,3 0 0,-1 0 0,1 0 0,1 0 0,1 0 0,-1 0 0,2 0 0,2 0 0,0 0 504,-10 0 1,2 0-505,9 0 0,2 0 0,-3 0 0,2-5 0,0-1 0,4 4 0,-1 1 0,-3-3 0,-4 0 0,1 0-243,-1 0 1,-1-1-1,0 2 243,-3 2 0,-1 1 0,0-2 0,3-1 0,0-2 0,0 2 0,4 2 0,1 1 0,2 1 1111,-1-1 1,1 0-1112,-2 0 0,2 0 0,-4 0 0,-4 0 0,10 0 0,0 0 0,-2 0 0,-1 0 410,1 0 1,0 0-411,-2 0 0,2 0 0,4 0 0,0 0 0,-5 0 0,-3 0 0,-7 0 0,-2 0 0,10 0 0,0 0 0,0 0-178,0 0 1,1 0 0,-2 0 177,-2 0 0,0 0 0,1 0 0,-6 0 0,1 0 0,4-5 0,0-3 0,0 3 0,3 3 0,0 1 0,0-1 0,-4-3 0,0-2 0,0 2 0,4 4 0,0 1 0,1 1 0,-1-1 0,1 0 0,1 0 0,-9 0 0,2 0 0,1 0 0,1 0 0,-2 0 0,0 0 0,1 0 0,1 0 0,6 0 0,0 0 0,-7 0 0,0 0 0,7 0 0,0 0 0,-8 0 0,-3 0 0,10 0 0,-2 0 0,2 0 0,-10 0 0,0 0 0,6 0 0,-2 0 0,2 0 0,-3 0 0,1 0 0,0 0 0,-1 0 0,1 0 0,5 0 0,0 1 0,1-2 0,-1-3 0,-1 0 0,-1 0-60,-3 3 1,-1 1 0,1-2 59,6-1 0,0-1 0,-1-1 0,-9-1 0,-3 0 0,1 1-388,8 3 1,1 2 0,0 0 0,-1-3 387,0-3 0,-1-2 0,-1-1 0,1 3 0,-3 4 0,0 1 0,-1 2 0,3-2 0,-3-2 0,2-1 0,1-1-3,0 1 0,0 0 0,3 0 3,0 3 0,3 0 0,5-6 0,1 2 0,-14 5 326,11 0 1,0 0-327,-14 0 802,13 0 0,0 0-802,-9 0 11,-1 0-11,5 0 0,-4 0 0,0 0 0,4 0 0,9 5 0,0 2 0,-9-5 0,3 4 0,0 0 0,-6 6 0,1-11 0,-2 1 0,8 13 0,0-1 0,-6-11 0,-1-1 0,-2 13 0,2-1 0,6-12 0,1-1 0,0 5 0,2 0 0,2-6 0,-4 0 0,-8 17 0,1-12 0,6 10 0,0-1 0,-3-11 0,9 3 0,0 0 0,3-6 0,-2 0 0,18 12 0,-12-9 0,-2 26 0,-1-25 0,3 26 0,12-27 0,0 26 0,0-24 0,0 24 0,12-26 0,-9 20 0,9-20 0,-12 27 0,0-14 0,0 16 0,0-10 0,0 0 0,0 2 0,0 1 0,0 8 0,0 0 0,0-2 0,0-2 0,0-2 0,0-1 0,0-5 0,0-2 0,0 2 0,0 8 0,0-13 0,-12 16 0,11-9 0,-1-1 0,-10 8 0,12 3 0,0-4 0,0-24 0,0 12 0,0-17 0,0 0 0,0 0 0</inkml:trace>
+  <inkml:trace contextRef="#ctx0" brushRef="#br0" timeOffset="15817">5662 12343 24575,'-15'0'0,"33"0"0,13 0 0,-7 0 0,5 0 0,0 0 0,0 0 0,0 0 0,1 0-698,-1 0 1,0 0 0,1 0 0,1 0 697,6 0 0,0 0 0,1 0 0,0 0-410,-6 0 1,0 0-1,0 0 1,1 0-1,0 0 410,3 0 0,1 0 0,0 0 0,1 0 0,-1 0-449,-3 0 1,-1 0-1,2 0 1,-1 0 0,0 0-1,-1 0 449,-1 0 0,-1-1 0,1 1 0,-1 0 0,1 0 0,0 1 0,2 0 0,1 1 0,1 0 0,-1 0 0,0 0 0,-2 1-347,2-1 0,-1 0 0,0 1 0,-1 0 0,1 1 347,1 2 0,0 1 0,0 0 0,0 0 0,-1-1 0,-2-2 0,-2-2 0,0 1 0,1 0 0,-1 1 0,2 1 0,0 1 0,-1 1 0,1-1 0,0-1 0,0-1 0,-1-1 0,1 0 0,0-1 0,0 1 0,0 0 0,0-1 0,0 0 0,-1 2 0,1 0-18,3 2 1,0 2 0,0 0 0,1-1 17,-6-3 0,2-1 0,-1 0 0,0 0 0,-1 0 0,0 2 0,-1 0 0,0 0 0,1 1 295,3 1 1,2 2 0,0-2 0,-3-1-296,-1-4 0,-2-1 0,1 1 722,4 3 1,0 2 0,-1-2-723,2-4 0,-1-2 0,-5 1 0,2 0 0,-1 0 0,-3 0 0,-1 0 0,2 0 0,5 0 0,2 0 0,1 0 128,-6 0 0,1 0 1,1 0-1,0 0-128,2 0 0,1 0 0,1 0 0,0 0 0,-5 0 0,1 0 0,0 0 0,0 0 0,0 0 0,0 0 0,0 0 0,0 0 0,0 0 0,-2 0 0,4 1 0,-1-1 0,-1 1 0,-1-3 542,7-3 0,0-2 0,-4 2-542,-2 3 0,-4-1 503,-1-6 1,-4 0-504,5 9 0,-4 0 0,2 0 0,9 0 0,2 0-445,-5 0 0,2 0 0,2 0 445,-1 0 0,3 0 0,0 0 0,1 0 0,-2 0 0,0 0 0,1 0 0,-1 0 0,-5 0 0,0 0 0,0 0 0,0 0 0,-1 0 0,5 0 0,-1 0 0,-1 0 0,-1 0 0,-3 0 0,-2 0 0,0 0 0,0 0 399,3 0 1,0 0 0,-1 0-400,1 0 0,0 0 0,-3 0 115,1 0 0,-1 0-115,3 0 0,-4 0 0,-7 0 0,4 0 1973,8 0-1973,-1 0 0,-7 0 0,4 0 0,-1 0 0,5 0 0,1 0-116,2 0 0,3 0 1,-1 0 115,-5 1 0,0-1 0,0-1 0,2-2 0,1-2 0,0 2 0,-1 2 0,-1 0 0,-1 0-203,-7-3 0,0-1 0,1 2 203,7 2 0,2 1 0,-3 1 0,-3-1 0,1 0 0,0 0 0,3 0 0,-2 0 0,1 0 0,-1 0-60,-5 0 1,0 0 0,0 0 59,8 0 0,-2 0 0,5 0 0,-10 0 0,-1 0 1070,-3 0-1070,5 0 0,2 0 638,6 0-638,-12 0 0,-4 0 0,-5 0 0,-3 0 0</inkml:trace>
+</inkml:ink>
+</file>
+
+<file path=ppt/ink/ink5.xml><?xml version="1.0" encoding="utf-8"?>
+<inkml:ink xmlns:inkml="http://www.w3.org/2003/InkML">
+  <inkml:definitions>
+    <inkml:context xml:id="ctx0">
+      <inkml:inkSource xml:id="inkSrc0">
+        <inkml:traceFormat>
+          <inkml:channel name="X" type="integer" min="-2.14748E9" max="2.14748E9" units="cm"/>
+          <inkml:channel name="Y" type="integer" min="-2.14748E9" max="2.14748E9" units="cm"/>
+          <inkml:channel name="F" type="integer" max="32767" units="dev"/>
+        </inkml:traceFormat>
+        <inkml:channelProperties>
+          <inkml:channelProperty channel="X" name="resolution" value="1000" units="1/cm"/>
+          <inkml:channelProperty channel="Y" name="resolution" value="1000" units="1/cm"/>
+          <inkml:channelProperty channel="F" name="resolution" value="0" units="1/dev"/>
+        </inkml:channelProperties>
+      </inkml:inkSource>
+      <inkml:timestamp xml:id="ts0" timeString="2026-03-18T20:14:41.600"/>
+    </inkml:context>
+    <inkml:brush xml:id="br0">
+      <inkml:brushProperty name="width" value="0.05292" units="cm"/>
+      <inkml:brushProperty name="height" value="0.05292" units="cm"/>
+      <inkml:brushProperty name="color" value="#FF0000"/>
+    </inkml:brush>
+  </inkml:definitions>
+  <inkml:trace contextRef="#ctx0" brushRef="#br0">1984 3585 24575,'28'0'0,"0"0"0,-2 0 0,1 0 0,1 0 0,7 0 0,1 0 0,2 0-387,-4 0 1,0 0 0,3 0 0,0 0 386,-5 0 0,2 0 0,0 0 0,1 0 0,-1 0 0,-3 0-438,7 0 1,-3 0 0,0 0 0,1 0 437,-2 0 0,2 0 0,0 0 0,-2 0 0,-5 0 0,9 0 0,-4 0-2,-7 0 1,1 0 0,0 0 1,0 0 0,1 0 0,2 0 0,0 0 0,1 0 0,2 0 0,0 0-499,0 0 1,1 0-1,1 0 1,0 0 498,-5 0 0,1 0 0,0 0 0,0 0 0,0 0 0,3 0 0,0 1 0,0-1 0,1-1 0,-3-1 0,1 0 0,1-1 0,0 0 0,0 1-377,-2 2 1,1 0-1,-1 0 1,1-1 0,1-1 376,-4-1 0,1-2 0,0 0 0,1-1 0,0 0 0,0 2-211,2 1 0,1 0 0,0 0 0,0 1 0,0 0 0,-1-1 211,-2 0 0,-2-1 0,1 0 0,-1 1 0,1-1 0,-1 1 0,1 1 0,0 0 0,0 0 0,0 0 0,0 0 0,-1 1-187,4-2 1,0 0 0,-1 1 0,-1 0-1,1 0 187,3 1 0,0 0 0,-1 1 0,1-1 0,-6-1 0,0-1 0,0 0 0,1 1 0,-2 0 0,6 1 0,0 1 0,-1 1 0,0-1 190,-1 0 1,0 0 0,-1 0 0,-1 0-191,3 0 0,-1 0 0,-3 0 1111,7 0 0,-5 0-1111,-5 0 2987,-11 0-2987,-5 0 2266,-9 12-2266,9-9 1134,-12 9-1134,0-1 0,0-8 0,0 9 0,-12-12 0,9 0 0,-9 0 0</inkml:trace>
+  <inkml:trace contextRef="#ctx0" brushRef="#br0" timeOffset="4434">1667 4339 24575,'0'-26'0,"0"-7"0,0 17 0,0-13 0,0 26 0,0 3 0,0 20 0,0 8 0,0 5 0,0-1 0,0-4 0,0 4 0,0-17 0,0 14 0,0-24 0,0 24 0,0-26 0,12 27 0,-9-26 0,8 25 0,-11-26 0,0-3 0,0-3 0,0-8 0</inkml:trace>
+  <inkml:trace contextRef="#ctx0" brushRef="#br0" timeOffset="14134">1733 4908 24575,'0'31'0,"0"0"0,0-8 0,0 1 0,0 2 0,0 3 0,0-2 0,0 4 0,0-2 0,0-3 0,0-3 0,0 9 0,0-2 0,0-14 0,0 4 0,0 4 0,0-4 0,0-3 0,0 0 0,0-5 0,0-9 0,0 9 0,0 5 0,0-12 0,0 24 0,0-26 0,0 9 0</inkml:trace>
+  <inkml:trace contextRef="#ctx0" brushRef="#br0" timeOffset="35967">4128 5226 24575,'29'0'0,"0"0"0,7 0 0,0 0 0,-9 0 0,-1 0 0,2 0-774,4-3 0,1-1 0,1-1 774,1-1 0,0-1 0,0-1 0,0 0 0,-2-1 0,1-2 0,1-1 0,-1-2 0,1 2 0,-7 4 0,0 2 0,-1-1 0,1 0 0,4-3 0,0-1 0,1 0 0,-1 0 0,1 0 0,0 0 0,-2 3 0,0-1 0,-3-1 371,-2-10 1,-1 1-372,8 11 0,-4 0 383,-13-10-383,13 18 0,-14 0 0,17 0 0,-4 0 0,2 0 0,3 0 0,3 0-3,-1 0 1,3 0-1,-1 0 3,-4 0 0,-1 0 0,0 0 0,5 0 0,0 0 0,-1 0 0,-4 0 0,-1 0 0,-1 0-100,-3 0 0,0 0 0,0 0 100,0 0 0,-1 0 0,-1 0 0,-1 0 0,0 0 0,8 0 0,-2 0 0,1 0 0,-9-1 0,0 2 1185,10 17-1185,-4-13 319,-7 12-319,-9-17 0,-12 0 0,29 0 0,-7 0 0,4 0 0,4 0-656,-1 0 1,4 0-1,2 0 1,2 0 0,-1 0 484,-5 0 1,1 1-1,0-1 1,2 1-1,-1-1 1,1-1-1,1 0-239,0-1 0,1-1 1,0-1-1,1 0 1,0-1-1,0 1 0,0 0 1,-1 1 289,0 0 0,-1 1 0,1 0 0,-1 0 1,0 0-1,0-1 0,0 1 0,-1-1 120,2-1 0,1-1 0,-1 1 0,-1-1 0,0 0 0,-1 0 0,0 0-165,0 0 0,-1 0 0,-1-1 0,0 1 0,-1 0 0,-2 2 165,5 1 0,-1 2 0,-2 0 0,-4-2 0,5-8 0,-4 2 0,-4 7 0,-7 2 0,-14-1 0,9 0 0</inkml:trace>
+  <inkml:trace contextRef="#ctx0" brushRef="#br0" timeOffset="37601">4405 5755 24575,'22'0'0,"0"0"0,6 0 0,2 0 0,2 0 0,-4 0 0,1 0 0,1 0 0,1 0-656,-1 0 1,1 0-1,2 0 1,-1 0 0,0 0 366,0 0 1,0 0 0,0 0 0,-1 0-1,1 0 289,0 0 0,0 0 0,-1 0 0,1 0 0,0 0 0,0 0 0,0 0 0,0 0 0,0 0 0,-1 0 0,4 0 0,0 0 0,0 0 0,1 0 0,-4 0 0,2 0 0,0 0 0,-1 0 0,0 0 0,3 0 0,0 0 0,-1 0 0,2 0 0,-4 0 0,2 0 0,0 0 0,0 0 0,-3 0 33,2 0 0,-1 0 0,-1 0 0,-1 0-33,7 0 0,0 0 0,-4 0 520,-3 0 0,-2 0-520,-3-1 0,2 0 0,-2 3 0,6 6 0,0 1 0,-6-6 0,1-3 0,1 2-197,3 3 0,1 2 1,-1-2 196,-5-4 0,-2-1 0,3-1 0,8 1 0,2 0 0,1 0 214,-10 0 1,0 0 0,1 0 0,-1 0-215,2 0 0,0 0 0,0 0 0,1 0 0,1 0 0,1 0 0,-1 0 0,1 0 0,2 3 0,0 0 0,0 1 0,-1-2 0,-4-1 0,-1-1 0,0 0 0,0 2 0,5 3 0,0 2 0,0 0 0,-2-2 0,3-4 0,-1-1 0,-2 2 269,-1 1 1,-2 2-1,0-2-269,8-2 0,-4-2 0,-5 1 0,-10 0 651,-18 0-651,0 0 0,0 0 0</inkml:trace>
+  <inkml:trace contextRef="#ctx0" brushRef="#br0" timeOffset="39917">1640 6231 24575,'0'32'0,"0"-5"0,0 4 0,0-6 0,0 1 0,0 3-820,0 4 1,0 3 0,0 1 0,0 0 370,0-1 1,0 0-1,0 0 1,0 2 448,0-8 0,0 3 0,0 0 0,0-1 0,0-1 0,0-2 351,0 7 1,0-3-1,0 1-351,0 3 0,0 1 0,0-11 924,0-10-924,0 0 0,0-17 0,0 0 0,0 0 0</inkml:trace>
+  <inkml:trace contextRef="#ctx0" brushRef="#br0" timeOffset="46767">1918 8401 24575,'26'0'0,"0"0"0,0 0 0,5 0 0,2 0 0,2 0 0,-3 0 0,2 0 0,2 0 0,0 0-656,-3 0 1,2 0-1,0 0 1,1 0 0,-2 0 270,-1 0 0,0 0 1,-1 0-1,1 0 0,1 0 385,-3 0 0,1 0 0,0 0 0,0 0 0,0 0 0,0 0 0,4 0 0,1 0 0,-1 0 0,-1 0 0,0 0 0,-2 0 0,-2 0 0,1 0 0,0 0 0,1 0 0,3 0 0,2 0 0,-1 0 0,0 0 0,-2 0-47,-1 0 1,-2 0 0,0 0 0,0 0 46,0 0 0,-1 0 0,1 0 0,-1 0 0,6 0 0,0 0 0,-1 0 0,1 0 0,0 0 0,-1 0 184,-3 0 0,-1 0 1,1 0-185,0 0 0,0 0 0,-1 0 0,5 0 0,-2 0 0,-7 0 0,-3 0 2468,3 0-2468,1 0 1556,-14 0-1556,17 0 0,-10 0 0,2 0 0,8 0 0,2 0 0,-3 0 0,1 0-74,2-4 1,3 0-1,-2 0 74,-8 3 0,-2 1 0,2-2-454,6-6 0,3-3 0,0-2 0,-1 4 454,-5 3 0,-1 2 0,-1 0 0,3-1 0,-2-1 0,0-1 0,2 1 0,-1-1 0,1 0-514,5-1 0,0 0 0,0 0 1,1 3 513,-7 3 0,1 1 0,0 2 0,0-1 0,-1-3 0,7-3 0,-1-2 0,1-1 0,0 3 0,-6 4 0,1 1 0,-1 2 0,0-1 0,0-1 0,2-1 0,-1-1 0,0-1 0,0 1-298,0 0 1,-1 0 0,0 0 0,0 1 297,0 0 0,1 2 0,-2 0 0,-1-1 194,1-3 1,-2-1-1,-1 2-194,0 2 0,0 1 0,-3 1 771,-1-1 1,-2 0-772,12 0 2179,-17 0-2179,13 0 1544,-26 0-1544,21 0 241,-4 0-241,7 0 0,4 0 0,-4 0 0,3 0 0,-1 0 0,1 0 0,1 0-221,-4 0 1,-1 0 0,1 0 220,4 0 0,0 0 0,0 0 0,0 0 0,0 0 0,0 0 0,-4 0 0,0 0 0,-1 0 0,1 0 0,0 0 0,-3 0 0,1 0 0,-1 0 0,3 0 0,-4 0 0,-7 0 0,2 0 0,-7 12 0,22-9 330,-13 3 1,2-1-331,4-4 0,1-2 0,3 1 0,-2 0 0,8 0 0,-3 0 0,-10 0 0,-20 0 0,27 0 0,-14 0 0,4 0 0,4 0 0,-4 0 0,2 0 0,2 0 0,-1 6 0,3 0 0,0-4 0,3-2 0,-2 1 0,2 5 0,1 0 0,-3-5 0,2-2 0,-3 1 0,-4 0 0,-1 0 0,11 0 0,-20 0 0,-12 0 0</inkml:trace>
+</inkml:ink>
+</file>
+
+<file path=ppt/ink/ink6.xml><?xml version="1.0" encoding="utf-8"?>
+<inkml:ink xmlns:inkml="http://www.w3.org/2003/InkML">
+  <inkml:definitions>
+    <inkml:context xml:id="ctx0">
+      <inkml:inkSource xml:id="inkSrc0">
+        <inkml:traceFormat>
+          <inkml:channel name="X" type="integer" min="-2.14748E9" max="2.14748E9" units="cm"/>
+          <inkml:channel name="Y" type="integer" min="-2.14748E9" max="2.14748E9" units="cm"/>
+          <inkml:channel name="F" type="integer" max="32767" units="dev"/>
+        </inkml:traceFormat>
+        <inkml:channelProperties>
+          <inkml:channelProperty channel="X" name="resolution" value="1000" units="1/cm"/>
+          <inkml:channelProperty channel="Y" name="resolution" value="1000" units="1/cm"/>
+          <inkml:channelProperty channel="F" name="resolution" value="0" units="1/dev"/>
+        </inkml:channelProperties>
+      </inkml:inkSource>
+      <inkml:timestamp xml:id="ts0" timeString="2026-03-18T20:15:40.384"/>
+    </inkml:context>
+    <inkml:brush xml:id="br0">
+      <inkml:brushProperty name="width" value="0.05292" units="cm"/>
+      <inkml:brushProperty name="height" value="0.05292" units="cm"/>
+      <inkml:brushProperty name="color" value="#FF0000"/>
+    </inkml:brush>
+  </inkml:definitions>
+  <inkml:trace contextRef="#ctx0" brushRef="#br0">7488 5067 24575,'34'0'0,"-9"0"0,-1 0 0,7 0 0,0 0 0,0 0 0,0 0 0,5 0 0,1 0 0,-17 0 0,0 0 0,18 0 0,-1 0 0,0 0 0,-14 0 0,-2 0 0,-6 0 0,14 0 0,-1 0 0,-3 0 0,3 0 0,7 0 0,2 0 0,-3 0 0,1 0 0,-9 0 0,0 0 0,0 0 0,8 0 0,-2 0 0,-1 0 0,-2 0 0,-2 0 0,-1 0 0,3 0 0,0 0 0,-5 0 0,0 0 0,9 0 0,-1 0 0,-11 0 0,0 0 0,5 0 0,-2 0 0,4 0 0,-7 0 0,8 0 0,-24 0 0,12 0 0,-5 0 0,3 0 0,5 0 0,4 0 0,0 0 0,0 0 0,1-6 0,-1 0 0,3 5 0,-4-1 0,-7-10 0,2 12 0</inkml:trace>
+  <inkml:trace contextRef="#ctx0" brushRef="#br0" timeOffset="1716">7527 5887 24575,'35'0'0,"0"0"0,0 0 0,-8 0 0,1 0 0,0 0 0,2 0 0,6 0 0,2 0 0,0 0 0,0 0-820,-1 0 1,0 0 0,1 0 0,0 0 501,-5 0 1,2 0 0,0 0 0,-1 0 0,-1 0 317,4 0 0,-2 0 0,-1 0 0,1 0-64,1 0 1,1 0 0,-1 0 0,-2 0 63,4 0 0,-3 0 0,1 0 337,-2 0 0,-1 0 1,-2 0-338,1 0 0,-3 0 0,-3 0 0,-2 0 0,3 0 2377,-6 0-2377,3 0 1562,-22 0-1562,10 0 165,6 0-165,-2 0 0,13 0 0,4 0 0,-7 0 0,-1 0 0,5 0 0,0 0 0,-3 0 0,-4 0 0,-6 0 0,0 0 0</inkml:trace>
+  <inkml:trace contextRef="#ctx0" brushRef="#br0" timeOffset="2083">9287 6099 24575,'0'0'0</inkml:trace>
+  <inkml:trace contextRef="#ctx0" brushRef="#br0" timeOffset="12000">13811 11523 24575,'26'0'0,"0"0"0,0 0 0,4 0 0,1 0 0,2 0 0,1 0 0,-4 0 0,0 0 0,2 0 0,0 0 0,1 0-547,2 0 1,1 0 0,1 0 0,1 0 0,1 0 0,0 0 136,-7 0 0,0 0 1,1 0-1,0 0 1,0 0-1,0 0 0,1 0 1,-1 0-1,1 0 0,0 0 1,1 0-1,-1 0 1,1 0-1,0 0 0,-1 0 1,1 0 286,1 0 0,-1 0 0,1 0 1,0 0-1,0 0 0,0 0 1,-1 0-1,0 0 123,-1 0 0,1 0 0,-1 0 0,0 0 0,-1 0 0,1 0 0,-1 0 0,-1 0-14,3 0 1,-1 0 0,-1 0-1,1 0 1,-1 0 0,0 0 0,-1 0 13,3-1 0,0 1 0,0 0 0,-1 0 0,0 0 0,-1 1-154,3 0 0,-1 1 1,0 1-1,-2-1 1,-2 1 153,8 2 0,-3 0 0,-2 0 903,-4 0 1,-1-1-1,-6 2-903,5 6 0,-10-12 0,-18 0 0</inkml:trace>
+  <inkml:trace contextRef="#ctx0" brushRef="#br0" timeOffset="40118">3426 7871 24575,'38'0'0,"-1"0"0,-8 0 0,1 0 0,1 0 0,-2 0 0,1 0 0,1 0 0,0 0-799,1 0 0,1 0 0,0 0 0,-1 0 799,-1 0 0,-1 0 0,0 0 0,0 0 0,-1 0 0,-1 0 0,1 0 0,-2 0 178,5 0 0,-1 0 1,-1 0-179,-4 0 0,0 0 0,0 0 0,-1 0 0,1 0 0,0 0 0,1 0 0,0 0 0,0 0 0,0 0 0,0 0 0,0 0 0,0 0 0,0 0 0,-3 0 315,1 0 1,-1 0-316,6 0 0,1 0 0,-6 0 0,-1 0 0,5 0 0,2 0 0,1 0 0,1 0 0,2 0 0,2 0 260,-11 0 1,1 0 0,1 0-261,4 0 0,1 0 0,0 0 0,2 0 0,0 0 0,1 0-239,-7 0 1,1 0 0,0 0 0,0 0 238,7 0 0,-1 0 0,0 0 0,-4 0 0,-1 0 0,-2 0 0,6 0 0,-5 0 0,-2 0 0,1 0 0,-26 0 809,27 0-809,-9 0 0,3 0 0,9 0 0,3 0-17,-3 0 1,3 0 0,0 0 16,-8 0 0,0 0 0,0 0 0,1 0 0,1 0 0,0 0 0,0 0 0,0 0 0,3 0 0,0 0 0,0 0 0,-1 0 0,5 0 0,-1 0 0,0 0 0,1 0 0,0 0 0,-1 0-194,-4 0 1,-1 0 0,-1 0 193,-3 0 0,0 0 0,0 0 0,-1 0 0,0 0 0,0 0 0,7 0 0,0 0 0,-3 0 0,0 0 0,-3 0 0,-1 0 0,3 0 0,-1 0 1397,9 0-1397,-6 0 0,0 0 624,0 0-624,-8 0 0,-2 0 0,-7 0 0,16 0 0,-14 0 0,2 0 0,2 0 0,8 0 0,2 0 0,3 0 0,3 0 0,-9 0 0,0 0 0,-1 0 0,6 0 0,-3 0 0,-5 0 0,-4 0 0,-5 0 0,-4 0 0,-11 12 0,0-9 0,0 9 0,0-12 0</inkml:trace>
+  <inkml:trace contextRef="#ctx0" brushRef="#br0" timeOffset="42467">2209 3770 24575,'0'34'0,"0"-10"0,0 2 0,0 3 0,0 2 0,0-5 0,0 1 0,0 1-355,0 3 0,0 0 0,0 0 355,0-4 0,0 0 0,0 0 0,0-1 0,0 0 0,0 0 0,0 0 0,0 0 0,0-1 0,0 10 0,0 0 0,0-10 0,0 1 0,0 0 0,0 1 0,-1-1 0,2-1 0,5 7 0,0 0 0,-4-2 0,-2 2 0,1 0 0,3-7 0,0 0 0,0 1-334,-3 10 0,-2 1 1,1 0 333,0-5 0,0 0 0,0 0 0,0 4 0,0 2 0,0-2 0,0-4 0,0 0 0,0-2 87,0-2 1,0-2 0,0 1-88,0-1 0,0 0 0,0-2 0,0 7 0,0-1 0,0-6 0,0 0 0,0 8 0,0-2 505,0 1-505,0-1 0,0 2 0,0-8 0,0 0 0,0 9 0,0 0 522,0-3 1,0 0-523,0 3 0,0-1 126,0-7 1,0-1-127,0 5 0,0-1 0,0-7 0,0-1 0,0 6 0,0 0 0,0-6 0,0 1 0,0 8 0,0-1 0,0 9 0,0-5 0,0-8 0,0-21 0,0 26 0,0-25 0,0 26 0,0-10 0,0 8 0,0 5 0,0-1 0,0-16 0,0 14 0,0-27 0,0 8 0,0 19 0,0-8 0,0 4 0,0-1 0,1 3 0,-2 0-265,-3 2 1,0 2 0,0-1 264,3 0 0,1 0 0,-2-1 0,-4 6 0,0-3 0,6-8 0,0-4 0,0-3 0,0-18 0</inkml:trace>
+</inkml:ink>
+</file>
+
+<file path=ppt/ink/ink7.xml><?xml version="1.0" encoding="utf-8"?>
+<inkml:ink xmlns:inkml="http://www.w3.org/2003/InkML">
+  <inkml:definitions>
+    <inkml:context xml:id="ctx0">
+      <inkml:inkSource xml:id="inkSrc0">
+        <inkml:traceFormat>
+          <inkml:channel name="X" type="integer" min="-2.14748E9" max="2.14748E9" units="cm"/>
+          <inkml:channel name="Y" type="integer" min="-2.14748E9" max="2.14748E9" units="cm"/>
+          <inkml:channel name="F" type="integer" max="32767" units="dev"/>
+        </inkml:traceFormat>
+        <inkml:channelProperties>
+          <inkml:channelProperty channel="X" name="resolution" value="1000" units="1/cm"/>
+          <inkml:channelProperty channel="Y" name="resolution" value="1000" units="1/cm"/>
+          <inkml:channelProperty channel="F" name="resolution" value="0" units="1/dev"/>
+        </inkml:channelProperties>
+      </inkml:inkSource>
+      <inkml:timestamp xml:id="ts0" timeString="2026-03-18T20:16:33.285"/>
+    </inkml:context>
+    <inkml:brush xml:id="br0">
+      <inkml:brushProperty name="width" value="0.05292" units="cm"/>
+      <inkml:brushProperty name="height" value="0.05292" units="cm"/>
+      <inkml:brushProperty name="color" value="#FF0000"/>
+    </inkml:brush>
+  </inkml:definitions>
+  <inkml:trace contextRef="#ctx0" brushRef="#br0">3149 4749 24575,'32'0'0,"-5"0"0,3 0 0,0 0 0,4 0 0,1 0-820,-2 0 1,1 0 0,2 0 0,2 0 363,-6 0 1,1 0 0,1 0 0,1 0 0,0 0 0,-1 0 455,-2 0 0,0 0 0,-1 0 0,1 0 0,0 0 0,1 0 0,3 0 0,2 0 0,-1 0 0,1 0 0,-2 0 0,0 0 0,-1 0 0,-1 0 0,-1 0 0,0 0 0,1 0-142,1 0 0,0 0 0,1 0 0,-1 0 0,-1 0 142,2 0 0,0 0 0,-2 0 0,1 0 162,-3 0 1,0 0-1,0 0 1,-2 0-163,4 0 0,-1 0 0,-1 0 0,-2 0 0,0 0 0,-1 0-154,6 0 0,-1 0 154,-4 0 0,1 0 0,-2 0 0,6 0 0,-1 0 0,-5 0 0,2 0 0,-1 0 0,-3 0 0,-1 0 0,2 0 0,2 0 0,2 0 0,-2 0 0,-2 0 0,-1 0 0,-1 0 0,11 0 0,-2 0 1337,-7 0 0,-3 0-1337,-4 0 0,-2 0 2225,1 0-2225,-8 18 1039,-12-14-1039,0 14 438,18-18-438,-14 0 0,26 0 0,-16 0 0,14 0 0,6 0 0,-3 0 0,3 0 0,-3 0 0,3 0 0,-1 0 0,-5 0 0,-1 0 0,-1 0 0,6 0 0,-4 0 0,5 0 0,-10 0 0,-20 0 0,9 0 0</inkml:trace>
+  <inkml:trace contextRef="#ctx0" brushRef="#br0" timeOffset="25216">9909 8030 24575,'25'0'0,"1"0"0,6 0 0,2 0 0,-8 0 0,1 0 0,1 0-355,3 0 0,0 0 0,0 0 355,-3 0 0,-1 0 0,-1 0 174,-1 0 1,-2 0-175,1 0 0,-7 0 176,-14 0-176,27 0 0,-14 0 0,7 0 0,4 0 0,-7 0 0,2 0 0,4 0 0,3 0 0,-1 0 0,1 0 0,0 0 0,2 0 0,2 0 0,-3 0 0,-3 1 0,-2-2 270,4-7 0,-1-2-270,-7 9 0,-4-2 0,0-15 0,0 18 0,-5 0 0,-9 0 0,21 0 0,-22 0 0,16 0 0,6 0 0,-1 0 0,2 0 0,0 1 0,3-1 0,0-1-426,4-2 1,1-2 0,0 2 425,-1 2 0,0 1 0,-1-2 0,-3-7 0,-1-3 0,-2 3 0,0 7 0,-3 0 0,2-8 0,-6 2 0,-14 8 0,25 0 0,-26 0 0,9 0 0</inkml:trace>
+  <inkml:trace contextRef="#ctx0" brushRef="#br0" timeOffset="29282">20174 7898 24575,'23'0'0,"-1"0"0,6 0 0,4 0 0,-1 0 0,3 0 0,-1 0-889,-1 0 1,0 0-1,1 0 889,-1 0 0,1 0 0,0 0 0,-3 0 0,-2 0 0,-3 0 0,2 0 282,5 0 1,1 0 0,-4 0-283,-7 0 0,-2 0 219,6 0 1,-2 0-220,4 0 0,-9 0 0,0 0 0,1 0 0,0 0 0,11 0 0,3 0 0,-8 0 0,1 1 0,1-2 174,2-3 0,2 0 0,0 0-174,0 3 0,2 0 0,-2 0 0,-1-2 0,0-1 0,0-1 0,0-1 0,-1 0 0,1 1 0,0 3 0,0 1 0,0-1 0,0-3 0,-1-2 0,2 2 0,0 3 0,1 3 0,0 0 0,-1-1 0,-1 0 0,0 0 0,2 0 0,0 0 0,0 0 0,-2 0 0,-1 0 0,1 0 0,4 0 0,0 0 0,0 0 0,-2 0 0,1 0 0,0 0 0,-5 0 0,1 0 0,0 0 0,-1 0 0,1 0 0,0 0 0,-1 0 0,2 0 0,-1 0 0,-1 0 0,2 0 0,-2 0 0,-2 0 0,-1 0 0,-5 0 0,-2 0 0,1 0 0,-8 0 0,18 0 857,6 0-857,-7 0 0,3 0 0,0-2 0,0 4 0,-7 6 0,-1 1 0,6-7 0,-3 1 0,-3 14 0,-4-15 0,1-4 0,-5 2 0,5 0 0,-10 0 0,-11 0 0,0 0 0,0 12 0,0-9 0,12 9 0,9-12 0,-5 0 0,1 0 0,-17-12-820,0 9 1,0-9 0,0 12 0</inkml:trace>
+  <inkml:trace contextRef="#ctx0" brushRef="#br0" timeOffset="40266">14790 7964 24575,'34'0'0,"-5"0"0,4 0 0,-8 0 0,2 0 0,2 0-1093,5 0 1,2 0 0,2 0 1062,-3 0 0,1 0 0,0 0 0,0 0-398,-1 0 0,0 0 1,0 0-1,1 0 428,-5 0 0,1 0 0,1 0 0,-1 0 0,-1 0 0,5 0 0,-1 0 0,0 0 0,0 0-79,1 0 0,0 0 0,0 0 0,-1 0 79,-5 0 0,0 0 0,0 0 0,0 0 0,0 0 0,0 0 0,0 0 0,-1 0-147,7 0 0,0 0 0,-2 0 147,-7 0 0,0 0 0,0 0 0,4 0 0,2 0 0,-3 0 0,-1 0 0,1 0 419,-3 0 0,1 0 1,-1 0-420,4 0 0,-2 0 1052,5 0 0,-2 0-1052,-6 0 0,-3 0 1743,9 0-1743,-8 0 594,-21 0-594,8 0 166,7 0-166,-2 0 0,8 0 0,2 0 0,-2 0 0,1 0 0,5 0 0,0 0 0,-3 0 0,-1 0 0,-6 1 0,0-2 0,0-8 0,-2 0 0,-2 5 0,2-14 0,-18 18 0</inkml:trace>
+  <inkml:trace contextRef="#ctx0" brushRef="#br0" timeOffset="42215">15266 4908 24575,'37'0'0,"0"0"0,-4 0 0,2 0 0,0 0 0,3 0 0,-1 0-564,-6 0 0,0 0 1,-1 0 563,1 0 0,0 0 0,0 0 0,0 0 0,0 0 0,0 0 0,-4 0 0,0 0 0,-1 0 273,9 0 1,-3 0-274,-8 0 0,-3 0 280,0 0-280,-9 0 0,-12 0 0,0 0 0,0 0 0</inkml:trace>
+  <inkml:trace contextRef="#ctx0" brushRef="#br0" timeOffset="43650">15200 5913 24575,'23'0'0,"0"0"0,8 0 0,3 0 0,-8 0 0,1 0 0,0 0-552,4 0 0,1 0 0,-1 0 552,2 0 0,0 0 0,0 0 0,-1 0 0,-1 0 0,-1 0 0,2 0 0,-1 0 268,1 0 0,-2 0-268,-3 0 274,-6 0-274,3 0 0,-22 18 0,10-14 846,-12 14-846,0-18 0,18 0 0,-2 0 0,7 0 0,4 0 0,-3 0 0,1 0 0,8 0 0,0 0 0,3 0 0,-12 0 0,-6 0 0,-15 0 0,8 0 0,-11 0 0</inkml:trace>
+  <inkml:trace contextRef="#ctx0" brushRef="#br0" timeOffset="44867">15108 7117 24575,'32'0'0,"-9"0"0,0 0 0,13 0 0,-3 0 0,-10 0 0,10 0 0,-5 0 0,7 0 0,3 0-656,-6 0 1,3 0-1,2 0 1,0 0 0,1 0 534,-7 0 1,1 0 0,0 0-1,1 0 1,0 0 0,0 0-1,0 0 121,1 0 0,0 0 0,1 0 0,0 0 0,-1 0 0,0 0 0,-1 0 0,3 0 0,-1 0 0,0 0 0,-2 0 0,0 0 0,-2 0-135,4 0 0,-2 0 0,-2 0 1,-1 0 134,3 0 0,-3 0 0,-3 0 0,-2 0 0,-6 0 0,-4 0 0,-3 0 0</inkml:trace>
+</inkml:ink>
 </file>
 
 <file path=ppt/notesMasters/notesMaster1.xml><?xml version="1.0" encoding="utf-8"?>
@@ -5938,6 +6208,57 @@
           </a:p>
         </p:txBody>
       </p:sp>
+      <mc:AlternateContent xmlns:mc="http://schemas.openxmlformats.org/markup-compatibility/2006">
+        <mc:Choice xmlns:p14="http://schemas.microsoft.com/office/powerpoint/2010/main" Requires="p14">
+          <p:contentPart p14:bwMode="auto" r:id="rId3">
+            <p14:nvContentPartPr>
+              <p14:cNvPr id="5" name="Ink 4">
+                <a:extLst>
+                  <a:ext uri="{FF2B5EF4-FFF2-40B4-BE49-F238E27FC236}">
+                    <a16:creationId xmlns:a16="http://schemas.microsoft.com/office/drawing/2014/main" id="{245D4A59-B75D-CDE3-C4E6-F40CF6C97054}"/>
+                  </a:ext>
+                </a:extLst>
+              </p14:cNvPr>
+              <p14:cNvContentPartPr/>
+              <p14:nvPr/>
+            </p14:nvContentPartPr>
+            <p14:xfrm>
+              <a:off x="409680" y="1733400"/>
+              <a:ext cx="4685040" cy="3072240"/>
+            </p14:xfrm>
+          </p:contentPart>
+        </mc:Choice>
+        <mc:Fallback>
+          <p:pic>
+            <p:nvPicPr>
+              <p:cNvPr id="5" name="Ink 4">
+                <a:extLst>
+                  <a:ext uri="{FF2B5EF4-FFF2-40B4-BE49-F238E27FC236}">
+                    <a16:creationId xmlns:a16="http://schemas.microsoft.com/office/drawing/2014/main" id="{245D4A59-B75D-CDE3-C4E6-F40CF6C97054}"/>
+                  </a:ext>
+                </a:extLst>
+              </p:cNvPr>
+              <p:cNvPicPr/>
+              <p:nvPr/>
+            </p:nvPicPr>
+            <p:blipFill>
+              <a:blip r:embed="rId4"/>
+              <a:stretch>
+                <a:fillRect/>
+              </a:stretch>
+            </p:blipFill>
+            <p:spPr>
+              <a:xfrm>
+                <a:off x="400320" y="1724040"/>
+                <a:ext cx="4703760" cy="3090960"/>
+              </a:xfrm>
+              <a:prstGeom prst="rect">
+                <a:avLst/>
+              </a:prstGeom>
+            </p:spPr>
+          </p:pic>
+        </mc:Fallback>
+      </mc:AlternateContent>
     </p:spTree>
   </p:cSld>
   <p:clrMapOvr>
@@ -7082,6 +7403,57 @@
           </a:p>
         </p:txBody>
       </p:sp>
+      <mc:AlternateContent xmlns:mc="http://schemas.openxmlformats.org/markup-compatibility/2006">
+        <mc:Choice xmlns:p14="http://schemas.microsoft.com/office/powerpoint/2010/main" Requires="p14">
+          <p:contentPart p14:bwMode="auto" r:id="rId3">
+            <p14:nvContentPartPr>
+              <p14:cNvPr id="8" name="Ink 7">
+                <a:extLst>
+                  <a:ext uri="{FF2B5EF4-FFF2-40B4-BE49-F238E27FC236}">
+                    <a16:creationId xmlns:a16="http://schemas.microsoft.com/office/drawing/2014/main" id="{2F7FAA2A-3FF9-F1E8-4D9C-6475248091C4}"/>
+                  </a:ext>
+                </a:extLst>
+              </p14:cNvPr>
+              <p14:cNvContentPartPr/>
+              <p14:nvPr/>
+            </p14:nvContentPartPr>
+            <p14:xfrm>
+              <a:off x="576360" y="1123920"/>
+              <a:ext cx="3648240" cy="619920"/>
+            </p14:xfrm>
+          </p:contentPart>
+        </mc:Choice>
+        <mc:Fallback>
+          <p:pic>
+            <p:nvPicPr>
+              <p:cNvPr id="8" name="Ink 7">
+                <a:extLst>
+                  <a:ext uri="{FF2B5EF4-FFF2-40B4-BE49-F238E27FC236}">
+                    <a16:creationId xmlns:a16="http://schemas.microsoft.com/office/drawing/2014/main" id="{2F7FAA2A-3FF9-F1E8-4D9C-6475248091C4}"/>
+                  </a:ext>
+                </a:extLst>
+              </p:cNvPr>
+              <p:cNvPicPr/>
+              <p:nvPr/>
+            </p:nvPicPr>
+            <p:blipFill>
+              <a:blip r:embed="rId4"/>
+              <a:stretch>
+                <a:fillRect/>
+              </a:stretch>
+            </p:blipFill>
+            <p:spPr>
+              <a:xfrm>
+                <a:off x="567000" y="1114560"/>
+                <a:ext cx="3666960" cy="638640"/>
+              </a:xfrm>
+              <a:prstGeom prst="rect">
+                <a:avLst/>
+              </a:prstGeom>
+            </p:spPr>
+          </p:pic>
+        </mc:Fallback>
+      </mc:AlternateContent>
     </p:spTree>
   </p:cSld>
   <p:clrMapOvr>
@@ -8224,6 +8596,57 @@
           </a:p>
         </p:txBody>
       </p:sp>
+      <mc:AlternateContent xmlns:mc="http://schemas.openxmlformats.org/markup-compatibility/2006">
+        <mc:Choice xmlns:p14="http://schemas.microsoft.com/office/powerpoint/2010/main" Requires="p14">
+          <p:contentPart p14:bwMode="auto" r:id="rId3">
+            <p14:nvContentPartPr>
+              <p14:cNvPr id="22" name="Ink 21">
+                <a:extLst>
+                  <a:ext uri="{FF2B5EF4-FFF2-40B4-BE49-F238E27FC236}">
+                    <a16:creationId xmlns:a16="http://schemas.microsoft.com/office/drawing/2014/main" id="{3E8A1C78-3F6C-D43E-C215-349264907BF0}"/>
+                  </a:ext>
+                </a:extLst>
+              </p14:cNvPr>
+              <p14:cNvContentPartPr/>
+              <p14:nvPr/>
+            </p14:nvContentPartPr>
+            <p14:xfrm>
+              <a:off x="338040" y="533160"/>
+              <a:ext cx="4467600" cy="2343960"/>
+            </p14:xfrm>
+          </p:contentPart>
+        </mc:Choice>
+        <mc:Fallback>
+          <p:pic>
+            <p:nvPicPr>
+              <p:cNvPr id="22" name="Ink 21">
+                <a:extLst>
+                  <a:ext uri="{FF2B5EF4-FFF2-40B4-BE49-F238E27FC236}">
+                    <a16:creationId xmlns:a16="http://schemas.microsoft.com/office/drawing/2014/main" id="{3E8A1C78-3F6C-D43E-C215-349264907BF0}"/>
+                  </a:ext>
+                </a:extLst>
+              </p:cNvPr>
+              <p:cNvPicPr/>
+              <p:nvPr/>
+            </p:nvPicPr>
+            <p:blipFill>
+              <a:blip r:embed="rId4"/>
+              <a:stretch>
+                <a:fillRect/>
+              </a:stretch>
+            </p:blipFill>
+            <p:spPr>
+              <a:xfrm>
+                <a:off x="328680" y="523800"/>
+                <a:ext cx="4486320" cy="2362680"/>
+              </a:xfrm>
+              <a:prstGeom prst="rect">
+                <a:avLst/>
+              </a:prstGeom>
+            </p:spPr>
+          </p:pic>
+        </mc:Fallback>
+      </mc:AlternateContent>
     </p:spTree>
   </p:cSld>
   <p:clrMapOvr>
@@ -11321,6 +11744,57 @@
           </a:p>
         </p:txBody>
       </p:sp>
+      <mc:AlternateContent xmlns:mc="http://schemas.openxmlformats.org/markup-compatibility/2006">
+        <mc:Choice xmlns:p14="http://schemas.microsoft.com/office/powerpoint/2010/main" Requires="p14">
+          <p:contentPart p14:bwMode="auto" r:id="rId3">
+            <p14:nvContentPartPr>
+              <p14:cNvPr id="10" name="Ink 9">
+                <a:extLst>
+                  <a:ext uri="{FF2B5EF4-FFF2-40B4-BE49-F238E27FC236}">
+                    <a16:creationId xmlns:a16="http://schemas.microsoft.com/office/drawing/2014/main" id="{104F93F5-5D3A-9CE9-A1F8-022A9BD05F83}"/>
+                  </a:ext>
+                </a:extLst>
+              </p14:cNvPr>
+              <p14:cNvContentPartPr/>
+              <p14:nvPr/>
+            </p14:nvContentPartPr>
+            <p14:xfrm>
+              <a:off x="1051920" y="681120"/>
+              <a:ext cx="4658760" cy="3853800"/>
+            </p14:xfrm>
+          </p:contentPart>
+        </mc:Choice>
+        <mc:Fallback>
+          <p:pic>
+            <p:nvPicPr>
+              <p:cNvPr id="10" name="Ink 9">
+                <a:extLst>
+                  <a:ext uri="{FF2B5EF4-FFF2-40B4-BE49-F238E27FC236}">
+                    <a16:creationId xmlns:a16="http://schemas.microsoft.com/office/drawing/2014/main" id="{104F93F5-5D3A-9CE9-A1F8-022A9BD05F83}"/>
+                  </a:ext>
+                </a:extLst>
+              </p:cNvPr>
+              <p:cNvPicPr/>
+              <p:nvPr/>
+            </p:nvPicPr>
+            <p:blipFill>
+              <a:blip r:embed="rId4"/>
+              <a:stretch>
+                <a:fillRect/>
+              </a:stretch>
+            </p:blipFill>
+            <p:spPr>
+              <a:xfrm>
+                <a:off x="1042560" y="671760"/>
+                <a:ext cx="4677480" cy="3872520"/>
+              </a:xfrm>
+              <a:prstGeom prst="rect">
+                <a:avLst/>
+              </a:prstGeom>
+            </p:spPr>
+          </p:pic>
+        </mc:Fallback>
+      </mc:AlternateContent>
     </p:spTree>
   </p:cSld>
   <p:clrMapOvr>
@@ -12201,6 +12675,57 @@
           </a:p>
         </p:txBody>
       </p:sp>
+      <mc:AlternateContent xmlns:mc="http://schemas.openxmlformats.org/markup-compatibility/2006">
+        <mc:Choice xmlns:p14="http://schemas.microsoft.com/office/powerpoint/2010/main" Requires="p14">
+          <p:contentPart p14:bwMode="auto" r:id="rId3">
+            <p14:nvContentPartPr>
+              <p14:cNvPr id="22" name="Ink 21">
+                <a:extLst>
+                  <a:ext uri="{FF2B5EF4-FFF2-40B4-BE49-F238E27FC236}">
+                    <a16:creationId xmlns:a16="http://schemas.microsoft.com/office/drawing/2014/main" id="{4609A55C-A692-B156-6516-C2AAE396F40A}"/>
+                  </a:ext>
+                </a:extLst>
+              </p14:cNvPr>
+              <p14:cNvContentPartPr/>
+              <p14:nvPr/>
+            </p14:nvContentPartPr>
+            <p14:xfrm>
+              <a:off x="590400" y="1247400"/>
+              <a:ext cx="2319840" cy="1777320"/>
+            </p14:xfrm>
+          </p:contentPart>
+        </mc:Choice>
+        <mc:Fallback>
+          <p:pic>
+            <p:nvPicPr>
+              <p:cNvPr id="22" name="Ink 21">
+                <a:extLst>
+                  <a:ext uri="{FF2B5EF4-FFF2-40B4-BE49-F238E27FC236}">
+                    <a16:creationId xmlns:a16="http://schemas.microsoft.com/office/drawing/2014/main" id="{4609A55C-A692-B156-6516-C2AAE396F40A}"/>
+                  </a:ext>
+                </a:extLst>
+              </p:cNvPr>
+              <p:cNvPicPr/>
+              <p:nvPr/>
+            </p:nvPicPr>
+            <p:blipFill>
+              <a:blip r:embed="rId4"/>
+              <a:stretch>
+                <a:fillRect/>
+              </a:stretch>
+            </p:blipFill>
+            <p:spPr>
+              <a:xfrm>
+                <a:off x="581040" y="1238040"/>
+                <a:ext cx="2338560" cy="1796040"/>
+              </a:xfrm>
+              <a:prstGeom prst="rect">
+                <a:avLst/>
+              </a:prstGeom>
+            </p:spPr>
+          </p:pic>
+        </mc:Fallback>
+      </mc:AlternateContent>
     </p:spTree>
   </p:cSld>
   <p:clrMapOvr>
@@ -12817,6 +13342,57 @@
           </a:p>
         </p:txBody>
       </p:sp>
+      <mc:AlternateContent xmlns:mc="http://schemas.openxmlformats.org/markup-compatibility/2006">
+        <mc:Choice xmlns:p14="http://schemas.microsoft.com/office/powerpoint/2010/main" Requires="p14">
+          <p:contentPart p14:bwMode="auto" r:id="rId3">
+            <p14:nvContentPartPr>
+              <p14:cNvPr id="13" name="Ink 12">
+                <a:extLst>
+                  <a:ext uri="{FF2B5EF4-FFF2-40B4-BE49-F238E27FC236}">
+                    <a16:creationId xmlns:a16="http://schemas.microsoft.com/office/drawing/2014/main" id="{12C507E8-7E33-CAD6-21D9-FB5C2F41A7FB}"/>
+                  </a:ext>
+                </a:extLst>
+              </p14:cNvPr>
+              <p14:cNvContentPartPr/>
+              <p14:nvPr/>
+            </p14:nvContentPartPr>
+            <p14:xfrm>
+              <a:off x="794880" y="1357200"/>
+              <a:ext cx="5087160" cy="2810520"/>
+            </p14:xfrm>
+          </p:contentPart>
+        </mc:Choice>
+        <mc:Fallback>
+          <p:pic>
+            <p:nvPicPr>
+              <p:cNvPr id="13" name="Ink 12">
+                <a:extLst>
+                  <a:ext uri="{FF2B5EF4-FFF2-40B4-BE49-F238E27FC236}">
+                    <a16:creationId xmlns:a16="http://schemas.microsoft.com/office/drawing/2014/main" id="{12C507E8-7E33-CAD6-21D9-FB5C2F41A7FB}"/>
+                  </a:ext>
+                </a:extLst>
+              </p:cNvPr>
+              <p:cNvPicPr/>
+              <p:nvPr/>
+            </p:nvPicPr>
+            <p:blipFill>
+              <a:blip r:embed="rId4"/>
+              <a:stretch>
+                <a:fillRect/>
+              </a:stretch>
+            </p:blipFill>
+            <p:spPr>
+              <a:xfrm>
+                <a:off x="785520" y="1347840"/>
+                <a:ext cx="5105880" cy="2829240"/>
+              </a:xfrm>
+              <a:prstGeom prst="rect">
+                <a:avLst/>
+              </a:prstGeom>
+            </p:spPr>
+          </p:pic>
+        </mc:Fallback>
+      </mc:AlternateContent>
     </p:spTree>
   </p:cSld>
   <p:clrMapOvr>
@@ -14444,6 +15020,57 @@
           </a:p>
         </p:txBody>
       </p:sp>
+      <mc:AlternateContent xmlns:mc="http://schemas.openxmlformats.org/markup-compatibility/2006">
+        <mc:Choice xmlns:p14="http://schemas.microsoft.com/office/powerpoint/2010/main" Requires="p14">
+          <p:contentPart p14:bwMode="auto" r:id="rId3">
+            <p14:nvContentPartPr>
+              <p14:cNvPr id="7" name="Ink 6">
+                <a:extLst>
+                  <a:ext uri="{FF2B5EF4-FFF2-40B4-BE49-F238E27FC236}">
+                    <a16:creationId xmlns:a16="http://schemas.microsoft.com/office/drawing/2014/main" id="{7346757B-0728-00F8-AD13-1EC6452B9915}"/>
+                  </a:ext>
+                </a:extLst>
+              </p14:cNvPr>
+              <p14:cNvContentPartPr/>
+              <p14:nvPr/>
+            </p14:nvContentPartPr>
+            <p14:xfrm>
+              <a:off x="1133640" y="1709640"/>
+              <a:ext cx="7229520" cy="1181880"/>
+            </p14:xfrm>
+          </p:contentPart>
+        </mc:Choice>
+        <mc:Fallback>
+          <p:pic>
+            <p:nvPicPr>
+              <p:cNvPr id="7" name="Ink 6">
+                <a:extLst>
+                  <a:ext uri="{FF2B5EF4-FFF2-40B4-BE49-F238E27FC236}">
+                    <a16:creationId xmlns:a16="http://schemas.microsoft.com/office/drawing/2014/main" id="{7346757B-0728-00F8-AD13-1EC6452B9915}"/>
+                  </a:ext>
+                </a:extLst>
+              </p:cNvPr>
+              <p:cNvPicPr/>
+              <p:nvPr/>
+            </p:nvPicPr>
+            <p:blipFill>
+              <a:blip r:embed="rId4"/>
+              <a:stretch>
+                <a:fillRect/>
+              </a:stretch>
+            </p:blipFill>
+            <p:spPr>
+              <a:xfrm>
+                <a:off x="1124280" y="1700280"/>
+                <a:ext cx="7248240" cy="1200600"/>
+              </a:xfrm>
+              <a:prstGeom prst="rect">
+                <a:avLst/>
+              </a:prstGeom>
+            </p:spPr>
+          </p:pic>
+        </mc:Fallback>
+      </mc:AlternateContent>
     </p:spTree>
   </p:cSld>
   <p:clrMapOvr>
@@ -22456,7 +23083,7 @@
           <p:nvPr>
             <p:extLst>
               <p:ext uri="{D42A27DB-BD31-4B8C-83A1-F6EECF244321}">
-                <p14:modId xmlns:p14="http://schemas.microsoft.com/office/powerpoint/2010/main" val="1579011935"/>
+                <p14:modId xmlns:p14="http://schemas.microsoft.com/office/powerpoint/2010/main" val="2612619164"/>
               </p:ext>
             </p:extLst>
           </p:nvPr>
@@ -23330,7 +23957,7 @@
                           <a:ea typeface="Calibri" pitchFamily="34" charset="-122"/>
                           <a:cs typeface="Calibri" pitchFamily="34" charset="-120"/>
                         </a:rPr>
-                        <a:t>Quicksort</a:t>
+                        <a:t>Optional: Quicksort</a:t>
                       </a:r>
                       <a:endParaRPr lang="en-US" sz="1300" dirty="0">
                         <a:latin typeface="Calibri" charset="0"/>
@@ -27269,7 +27896,7 @@
                 <a:ea typeface="Calibri" pitchFamily="34" charset="-122"/>
                 <a:cs typeface="Calibri" pitchFamily="34" charset="-120"/>
               </a:rPr>
-              <a:t>Test Cases to Always Include:</a:t>
+              <a:t>Test Cases:</a:t>
             </a:r>
             <a:endParaRPr lang="en-US" sz="1600" dirty="0"/>
           </a:p>
@@ -28747,6 +29374,68 @@
           </a:graphicData>
         </a:graphic>
       </p:graphicFrame>
+      <p:sp>
+        <p:nvSpPr>
+          <p:cNvPr id="7" name="TextBox 6">
+            <a:extLst>
+              <a:ext uri="{FF2B5EF4-FFF2-40B4-BE49-F238E27FC236}">
+                <a16:creationId xmlns:a16="http://schemas.microsoft.com/office/drawing/2014/main" id="{E85ADFE7-71F3-7486-4513-62200AEEEDAD}"/>
+              </a:ext>
+            </a:extLst>
+          </p:cNvPr>
+          <p:cNvSpPr txBox="1"/>
+          <p:nvPr/>
+        </p:nvSpPr>
+        <p:spPr>
+          <a:xfrm>
+            <a:off x="7325904" y="1689926"/>
+            <a:ext cx="1626071" cy="1200329"/>
+          </a:xfrm>
+          <a:prstGeom prst="rect">
+            <a:avLst/>
+          </a:prstGeom>
+          <a:solidFill>
+            <a:schemeClr val="accent4">
+              <a:lumMod val="40000"/>
+              <a:lumOff val="60000"/>
+            </a:schemeClr>
+          </a:solidFill>
+        </p:spPr>
+        <p:txBody>
+          <a:bodyPr wrap="square" rtlCol="0">
+            <a:spAutoFit/>
+          </a:bodyPr>
+          <a:lstStyle/>
+          <a:p>
+            <a:pPr algn="ctr"/>
+            <a:r>
+              <a:rPr lang="en-US" dirty="0"/>
+              <a:t>Also test:</a:t>
+            </a:r>
+            <a:br>
+              <a:rPr lang="en-US" dirty="0"/>
+            </a:br>
+            <a:r>
+              <a:rPr lang="en-US" dirty="0"/>
+              <a:t>{1, 2}</a:t>
+            </a:r>
+            <a:br>
+              <a:rPr lang="en-US" dirty="0"/>
+            </a:br>
+            <a:r>
+              <a:rPr lang="en-US" dirty="0"/>
+              <a:t>{2, 1}</a:t>
+            </a:r>
+            <a:br>
+              <a:rPr lang="en-US" dirty="0"/>
+            </a:br>
+            <a:r>
+              <a:rPr lang="en-US" dirty="0"/>
+              <a:t>{2, 2}</a:t>
+            </a:r>
+          </a:p>
+        </p:txBody>
+      </p:sp>
     </p:spTree>
   </p:cSld>
   <p:clrMapOvr>

</xml_diff>